<commit_message>
Update ETF lineup and fill period returns
- 코리아TOP10 → 반도체TOP10 (국내 반도체 시총 상위 집중, 매우높은위험)
- TIGER CD금리플러스액티브 삭제, 나머지 ETF로 비중 재조정
  · 30%: 미국반도체12/글로벌AI9/반도체TOP10 9
  · 50%: 20/15/11 + 차이나반도체4
  · 70%: 28/22/14 + 차이나반도체6
- 기간별 수익률(1·3·6개월·1년) 입력, 상승(+) 적색·하락(−) 청색 표기
- 요약/투자포인트 문구를 파킹형 제외에 맞게 수정

Co-Authored-By: Claude Opus 4.8 <noreply@anthropic.com>
Claude-Session: https://claude.ai/code/session_01XEfuuowQFYqDWT5VUXsrtZ
</commit_message>
<xml_diff>
--- a/퇴직연금DC_제안서_위험자산비중별_202607.pptx
+++ b/퇴직연금DC_제안서_위험자산비중별_202607.pptx
@@ -4089,7 +4089,7 @@
         </p:nvGraphicFramePr>
         <p:xfrm>
           <a:off x="457200" y="1234440"/>
-          <a:ext cx="7635240" cy="4571996"/>
+          <a:ext cx="7635240" cy="4572000"/>
         </p:xfrm>
         <a:graphic>
           <a:graphicData uri="http://schemas.openxmlformats.org/drawingml/2006/table">
@@ -4448,7 +4448,7 @@
                   </a:tcPr>
                 </a:tc>
               </a:tr>
-              <a:tr h="797356">
+              <a:tr h="996696">
                 <a:tc>
                   <a:txBody>
                     <a:bodyPr wrap="square"/>
@@ -4556,7 +4556,7 @@
                           <a:latin typeface="맑은 고딕"/>
                           <a:ea typeface="맑은 고딕"/>
                         </a:rPr>
-                        <a:t>10</a:t>
+                        <a:t>12</a:t>
                       </a:r>
                     </a:p>
                   </a:txBody>
@@ -4597,14 +4597,14 @@
                     <a:p>
                       <a:pPr algn="ctr"/>
                       <a:r>
-                        <a:rPr sz="950" b="0">
-                          <a:solidFill>
-                            <a:srgbClr val="5A6372"/>
-                          </a:solidFill>
-                          <a:latin typeface="맑은 고딕"/>
-                          <a:ea typeface="맑은 고딕"/>
-                        </a:rPr>
-                        <a:t>–</a:t>
+                        <a:rPr sz="900" b="1">
+                          <a:solidFill>
+                            <a:srgbClr val="1F6FB2"/>
+                          </a:solidFill>
+                          <a:latin typeface="맑은 고딕"/>
+                          <a:ea typeface="맑은 고딕"/>
+                        </a:rPr>
+                        <a:t>-7.72</a:t>
                       </a:r>
                     </a:p>
                   </a:txBody>
@@ -4621,14 +4621,14 @@
                     <a:p>
                       <a:pPr algn="ctr"/>
                       <a:r>
-                        <a:rPr sz="950" b="0">
-                          <a:solidFill>
-                            <a:srgbClr val="5A6372"/>
-                          </a:solidFill>
-                          <a:latin typeface="맑은 고딕"/>
-                          <a:ea typeface="맑은 고딕"/>
-                        </a:rPr>
-                        <a:t>–</a:t>
+                        <a:rPr sz="900" b="1">
+                          <a:solidFill>
+                            <a:srgbClr val="C0392B"/>
+                          </a:solidFill>
+                          <a:latin typeface="맑은 고딕"/>
+                          <a:ea typeface="맑은 고딕"/>
+                        </a:rPr>
+                        <a:t>+36.51</a:t>
                       </a:r>
                     </a:p>
                   </a:txBody>
@@ -4645,14 +4645,14 @@
                     <a:p>
                       <a:pPr algn="ctr"/>
                       <a:r>
-                        <a:rPr sz="950" b="0">
-                          <a:solidFill>
-                            <a:srgbClr val="5A6372"/>
-                          </a:solidFill>
-                          <a:latin typeface="맑은 고딕"/>
-                          <a:ea typeface="맑은 고딕"/>
-                        </a:rPr>
-                        <a:t>–</a:t>
+                        <a:rPr sz="900" b="1">
+                          <a:solidFill>
+                            <a:srgbClr val="C0392B"/>
+                          </a:solidFill>
+                          <a:latin typeface="맑은 고딕"/>
+                          <a:ea typeface="맑은 고딕"/>
+                        </a:rPr>
+                        <a:t>+62.40</a:t>
                       </a:r>
                     </a:p>
                   </a:txBody>
@@ -4669,14 +4669,14 @@
                     <a:p>
                       <a:pPr algn="ctr"/>
                       <a:r>
-                        <a:rPr sz="950" b="0">
-                          <a:solidFill>
-                            <a:srgbClr val="5A6372"/>
-                          </a:solidFill>
-                          <a:latin typeface="맑은 고딕"/>
-                          <a:ea typeface="맑은 고딕"/>
-                        </a:rPr>
-                        <a:t>–</a:t>
+                        <a:rPr sz="900" b="1">
+                          <a:solidFill>
+                            <a:srgbClr val="C0392B"/>
+                          </a:solidFill>
+                          <a:latin typeface="맑은 고딕"/>
+                          <a:ea typeface="맑은 고딕"/>
+                        </a:rPr>
+                        <a:t>+133.88</a:t>
                       </a:r>
                     </a:p>
                   </a:txBody>
@@ -4687,7 +4687,7 @@
                   </a:tcPr>
                 </a:tc>
               </a:tr>
-              <a:tr h="797356">
+              <a:tr h="996696">
                 <a:tc>
                   <a:txBody>
                     <a:bodyPr wrap="square"/>
@@ -4795,7 +4795,7 @@
                           <a:latin typeface="맑은 고딕"/>
                           <a:ea typeface="맑은 고딕"/>
                         </a:rPr>
-                        <a:t>8</a:t>
+                        <a:t>9</a:t>
                       </a:r>
                     </a:p>
                   </a:txBody>
@@ -4836,14 +4836,14 @@
                     <a:p>
                       <a:pPr algn="ctr"/>
                       <a:r>
-                        <a:rPr sz="950" b="0">
-                          <a:solidFill>
-                            <a:srgbClr val="5A6372"/>
-                          </a:solidFill>
-                          <a:latin typeface="맑은 고딕"/>
-                          <a:ea typeface="맑은 고딕"/>
-                        </a:rPr>
-                        <a:t>–</a:t>
+                        <a:rPr sz="900" b="1">
+                          <a:solidFill>
+                            <a:srgbClr val="1F6FB2"/>
+                          </a:solidFill>
+                          <a:latin typeface="맑은 고딕"/>
+                          <a:ea typeface="맑은 고딕"/>
+                        </a:rPr>
+                        <a:t>-12.27</a:t>
                       </a:r>
                     </a:p>
                   </a:txBody>
@@ -4860,14 +4860,14 @@
                     <a:p>
                       <a:pPr algn="ctr"/>
                       <a:r>
-                        <a:rPr sz="950" b="0">
-                          <a:solidFill>
-                            <a:srgbClr val="5A6372"/>
-                          </a:solidFill>
-                          <a:latin typeface="맑은 고딕"/>
-                          <a:ea typeface="맑은 고딕"/>
-                        </a:rPr>
-                        <a:t>–</a:t>
+                        <a:rPr sz="900" b="1">
+                          <a:solidFill>
+                            <a:srgbClr val="C0392B"/>
+                          </a:solidFill>
+                          <a:latin typeface="맑은 고딕"/>
+                          <a:ea typeface="맑은 고딕"/>
+                        </a:rPr>
+                        <a:t>+23.93</a:t>
                       </a:r>
                     </a:p>
                   </a:txBody>
@@ -4884,14 +4884,14 @@
                     <a:p>
                       <a:pPr algn="ctr"/>
                       <a:r>
-                        <a:rPr sz="950" b="0">
-                          <a:solidFill>
-                            <a:srgbClr val="5A6372"/>
-                          </a:solidFill>
-                          <a:latin typeface="맑은 고딕"/>
-                          <a:ea typeface="맑은 고딕"/>
-                        </a:rPr>
-                        <a:t>–</a:t>
+                        <a:rPr sz="900" b="1">
+                          <a:solidFill>
+                            <a:srgbClr val="C0392B"/>
+                          </a:solidFill>
+                          <a:latin typeface="맑은 고딕"/>
+                          <a:ea typeface="맑은 고딕"/>
+                        </a:rPr>
+                        <a:t>+45.90</a:t>
                       </a:r>
                     </a:p>
                   </a:txBody>
@@ -4908,14 +4908,14 @@
                     <a:p>
                       <a:pPr algn="ctr"/>
                       <a:r>
-                        <a:rPr sz="950" b="0">
-                          <a:solidFill>
-                            <a:srgbClr val="5A6372"/>
-                          </a:solidFill>
-                          <a:latin typeface="맑은 고딕"/>
-                          <a:ea typeface="맑은 고딕"/>
-                        </a:rPr>
-                        <a:t>–</a:t>
+                        <a:rPr sz="900" b="1">
+                          <a:solidFill>
+                            <a:srgbClr val="C0392B"/>
+                          </a:solidFill>
+                          <a:latin typeface="맑은 고딕"/>
+                          <a:ea typeface="맑은 고딕"/>
+                        </a:rPr>
+                        <a:t>+94.51</a:t>
                       </a:r>
                     </a:p>
                   </a:txBody>
@@ -4926,7 +4926,7 @@
                   </a:tcPr>
                 </a:tc>
               </a:tr>
-              <a:tr h="797356">
+              <a:tr h="996696">
                 <a:tc>
                   <a:txBody>
                     <a:bodyPr wrap="square"/>
@@ -4969,7 +4969,7 @@
                           <a:latin typeface="맑은 고딕"/>
                           <a:ea typeface="맑은 고딕"/>
                         </a:rPr>
-                        <a:t>TIGER 코리아TOP10</a:t>
+                        <a:t>TIGER 반도체TOP10</a:t>
                       </a:r>
                     </a:p>
                     <a:p>
@@ -4986,7 +4986,7 @@
                           <a:latin typeface="맑은 고딕"/>
                           <a:ea typeface="맑은 고딕"/>
                         </a:rPr>
-                        <a:t>국내 시총 상위 10종목 · 메모리 부족·CAPEX 확산의 한국 반도체 수혜</a:t>
+                        <a:t>국내 반도체 시총 상위 10종목 · 메모리 부족·CAPEX 확산의 한국 반도체 집중 수혜</a:t>
                       </a:r>
                     </a:p>
                   </a:txBody>
@@ -5005,12 +5005,12 @@
                       <a:r>
                         <a:rPr sz="900" b="1">
                           <a:solidFill>
-                            <a:srgbClr val="E0671B"/>
-                          </a:solidFill>
-                          <a:latin typeface="맑은 고딕"/>
-                          <a:ea typeface="맑은 고딕"/>
-                        </a:rPr>
-                        <a:t>높은위험</a:t>
+                            <a:srgbClr val="C0392B"/>
+                          </a:solidFill>
+                          <a:latin typeface="맑은 고딕"/>
+                          <a:ea typeface="맑은 고딕"/>
+                        </a:rPr>
+                        <a:t>매우높은위험</a:t>
                       </a:r>
                     </a:p>
                   </a:txBody>
@@ -5034,7 +5034,7 @@
                           <a:latin typeface="맑은 고딕"/>
                           <a:ea typeface="맑은 고딕"/>
                         </a:rPr>
-                        <a:t>7</a:t>
+                        <a:t>9</a:t>
                       </a:r>
                     </a:p>
                   </a:txBody>
@@ -5075,14 +5075,14 @@
                     <a:p>
                       <a:pPr algn="ctr"/>
                       <a:r>
-                        <a:rPr sz="950" b="0">
-                          <a:solidFill>
-                            <a:srgbClr val="5A6372"/>
-                          </a:solidFill>
-                          <a:latin typeface="맑은 고딕"/>
-                          <a:ea typeface="맑은 고딕"/>
-                        </a:rPr>
-                        <a:t>–</a:t>
+                        <a:rPr sz="900" b="1">
+                          <a:solidFill>
+                            <a:srgbClr val="1F6FB2"/>
+                          </a:solidFill>
+                          <a:latin typeface="맑은 고딕"/>
+                          <a:ea typeface="맑은 고딕"/>
+                        </a:rPr>
+                        <a:t>-32.23</a:t>
                       </a:r>
                     </a:p>
                   </a:txBody>
@@ -5099,14 +5099,14 @@
                     <a:p>
                       <a:pPr algn="ctr"/>
                       <a:r>
-                        <a:rPr sz="950" b="0">
-                          <a:solidFill>
-                            <a:srgbClr val="5A6372"/>
-                          </a:solidFill>
-                          <a:latin typeface="맑은 고딕"/>
-                          <a:ea typeface="맑은 고딕"/>
-                        </a:rPr>
-                        <a:t>–</a:t>
+                        <a:rPr sz="900" b="1">
+                          <a:solidFill>
+                            <a:srgbClr val="C0392B"/>
+                          </a:solidFill>
+                          <a:latin typeface="맑은 고딕"/>
+                          <a:ea typeface="맑은 고딕"/>
+                        </a:rPr>
+                        <a:t>+3.82</a:t>
                       </a:r>
                     </a:p>
                   </a:txBody>
@@ -5123,14 +5123,14 @@
                     <a:p>
                       <a:pPr algn="ctr"/>
                       <a:r>
-                        <a:rPr sz="950" b="0">
-                          <a:solidFill>
-                            <a:srgbClr val="5A6372"/>
-                          </a:solidFill>
-                          <a:latin typeface="맑은 고딕"/>
-                          <a:ea typeface="맑은 고딕"/>
-                        </a:rPr>
-                        <a:t>–</a:t>
+                        <a:rPr sz="900" b="1">
+                          <a:solidFill>
+                            <a:srgbClr val="C0392B"/>
+                          </a:solidFill>
+                          <a:latin typeface="맑은 고딕"/>
+                          <a:ea typeface="맑은 고딕"/>
+                        </a:rPr>
+                        <a:t>+54.79</a:t>
                       </a:r>
                     </a:p>
                   </a:txBody>
@@ -5147,14 +5147,14 @@
                     <a:p>
                       <a:pPr algn="ctr"/>
                       <a:r>
-                        <a:rPr sz="950" b="0">
-                          <a:solidFill>
-                            <a:srgbClr val="5A6372"/>
-                          </a:solidFill>
-                          <a:latin typeface="맑은 고딕"/>
-                          <a:ea typeface="맑은 고딕"/>
-                        </a:rPr>
-                        <a:t>–</a:t>
+                        <a:rPr sz="900" b="1">
+                          <a:solidFill>
+                            <a:srgbClr val="C0392B"/>
+                          </a:solidFill>
+                          <a:latin typeface="맑은 고딕"/>
+                          <a:ea typeface="맑은 고딕"/>
+                        </a:rPr>
+                        <a:t>+198.59</a:t>
                       </a:r>
                     </a:p>
                   </a:txBody>
@@ -5165,7 +5165,7 @@
                   </a:tcPr>
                 </a:tc>
               </a:tr>
-              <a:tr h="797356">
+              <a:tr h="996696">
                 <a:tc>
                   <a:txBody>
                     <a:bodyPr wrap="square"/>
@@ -5175,18 +5175,18 @@
                       <a:r>
                         <a:rPr sz="1050" b="1">
                           <a:solidFill>
-                            <a:srgbClr val="F26A1B"/>
-                          </a:solidFill>
-                          <a:latin typeface="맑은 고딕"/>
-                          <a:ea typeface="맑은 고딕"/>
-                        </a:rPr>
-                        <a:t>ETF</a:t>
-                      </a:r>
-                    </a:p>
-                  </a:txBody>
-                  <a:tcPr anchor="ctr" marL="50800" marR="50800" marT="25400" marB="25400">
-                    <a:solidFill>
-                      <a:srgbClr val="EEF2F7"/>
+                            <a:srgbClr val="2E6DB4"/>
+                          </a:solidFill>
+                          <a:latin typeface="맑은 고딕"/>
+                          <a:ea typeface="맑은 고딕"/>
+                        </a:rPr>
+                        <a:t>예금</a:t>
+                      </a:r>
+                    </a:p>
+                  </a:txBody>
+                  <a:tcPr anchor="ctr" marL="50800" marR="50800" marT="25400" marB="25400">
+                    <a:solidFill>
+                      <a:srgbClr val="EFF3F9"/>
                     </a:solidFill>
                   </a:tcPr>
                 </a:tc>
@@ -5203,12 +5203,12 @@
                       <a:r>
                         <a:rPr sz="1050" b="1">
                           <a:solidFill>
-                            <a:srgbClr val="222A38"/>
-                          </a:solidFill>
-                          <a:latin typeface="맑은 고딕"/>
-                          <a:ea typeface="맑은 고딕"/>
-                        </a:rPr>
-                        <a:t>TIGER CD금리플러스액티브</a:t>
+                            <a:srgbClr val="142A4C"/>
+                          </a:solidFill>
+                          <a:latin typeface="맑은 고딕"/>
+                          <a:ea typeface="맑은 고딕"/>
+                        </a:rPr>
+                        <a:t>한국증권금융 정기예금</a:t>
                       </a:r>
                     </a:p>
                     <a:p>
@@ -5225,229 +5225,7 @@
                           <a:latin typeface="맑은 고딕"/>
                           <a:ea typeface="맑은 고딕"/>
                         </a:rPr>
-                        <a:t>국내 91일물 CD금리 추종 파킹형 · 시장 변동성 확대 대비 유동성 확보</a:t>
-                      </a:r>
-                    </a:p>
-                  </a:txBody>
-                  <a:tcPr anchor="ctr" marL="50800" marR="50800" marT="25400" marB="25400">
-                    <a:solidFill>
-                      <a:srgbClr val="EEF2F7"/>
-                    </a:solidFill>
-                  </a:tcPr>
-                </a:tc>
-                <a:tc>
-                  <a:txBody>
-                    <a:bodyPr wrap="square"/>
-                    <a:lstStyle/>
-                    <a:p>
-                      <a:pPr algn="ctr"/>
-                      <a:r>
-                        <a:rPr sz="900" b="1">
-                          <a:solidFill>
-                            <a:srgbClr val="C99A06"/>
-                          </a:solidFill>
-                          <a:latin typeface="맑은 고딕"/>
-                          <a:ea typeface="맑은 고딕"/>
-                        </a:rPr>
-                        <a:t>보통위험</a:t>
-                      </a:r>
-                    </a:p>
-                  </a:txBody>
-                  <a:tcPr anchor="ctr" marL="50800" marR="50800" marT="25400" marB="25400">
-                    <a:solidFill>
-                      <a:srgbClr val="EEF2F7"/>
-                    </a:solidFill>
-                  </a:tcPr>
-                </a:tc>
-                <a:tc>
-                  <a:txBody>
-                    <a:bodyPr wrap="square"/>
-                    <a:lstStyle/>
-                    <a:p>
-                      <a:pPr algn="ctr"/>
-                      <a:r>
-                        <a:rPr sz="1300" b="1">
-                          <a:solidFill>
-                            <a:srgbClr val="F26A1B"/>
-                          </a:solidFill>
-                          <a:latin typeface="맑은 고딕"/>
-                          <a:ea typeface="맑은 고딕"/>
-                        </a:rPr>
-                        <a:t>5</a:t>
-                      </a:r>
-                    </a:p>
-                  </a:txBody>
-                  <a:tcPr anchor="ctr" marL="50800" marR="50800" marT="25400" marB="25400">
-                    <a:solidFill>
-                      <a:srgbClr val="EEF2F7"/>
-                    </a:solidFill>
-                  </a:tcPr>
-                </a:tc>
-                <a:tc>
-                  <a:txBody>
-                    <a:bodyPr wrap="square"/>
-                    <a:lstStyle/>
-                    <a:p>
-                      <a:pPr algn="ctr"/>
-                      <a:r>
-                        <a:rPr sz="1050" b="0">
-                          <a:solidFill>
-                            <a:srgbClr val="5A6372"/>
-                          </a:solidFill>
-                          <a:latin typeface="맑은 고딕"/>
-                          <a:ea typeface="맑은 고딕"/>
-                        </a:rPr>
-                        <a:t>–</a:t>
-                      </a:r>
-                    </a:p>
-                  </a:txBody>
-                  <a:tcPr anchor="ctr" marL="50800" marR="50800" marT="25400" marB="25400">
-                    <a:solidFill>
-                      <a:srgbClr val="EEF2F7"/>
-                    </a:solidFill>
-                  </a:tcPr>
-                </a:tc>
-                <a:tc>
-                  <a:txBody>
-                    <a:bodyPr wrap="square"/>
-                    <a:lstStyle/>
-                    <a:p>
-                      <a:pPr algn="ctr"/>
-                      <a:r>
-                        <a:rPr sz="950" b="0">
-                          <a:solidFill>
-                            <a:srgbClr val="5A6372"/>
-                          </a:solidFill>
-                          <a:latin typeface="맑은 고딕"/>
-                          <a:ea typeface="맑은 고딕"/>
-                        </a:rPr>
-                        <a:t>–</a:t>
-                      </a:r>
-                    </a:p>
-                  </a:txBody>
-                  <a:tcPr anchor="ctr" marL="50800" marR="50800" marT="25400" marB="25400">
-                    <a:solidFill>
-                      <a:srgbClr val="EEF2F7"/>
-                    </a:solidFill>
-                  </a:tcPr>
-                </a:tc>
-                <a:tc>
-                  <a:txBody>
-                    <a:bodyPr wrap="square"/>
-                    <a:lstStyle/>
-                    <a:p>
-                      <a:pPr algn="ctr"/>
-                      <a:r>
-                        <a:rPr sz="950" b="0">
-                          <a:solidFill>
-                            <a:srgbClr val="5A6372"/>
-                          </a:solidFill>
-                          <a:latin typeface="맑은 고딕"/>
-                          <a:ea typeface="맑은 고딕"/>
-                        </a:rPr>
-                        <a:t>–</a:t>
-                      </a:r>
-                    </a:p>
-                  </a:txBody>
-                  <a:tcPr anchor="ctr" marL="50800" marR="50800" marT="25400" marB="25400">
-                    <a:solidFill>
-                      <a:srgbClr val="EEF2F7"/>
-                    </a:solidFill>
-                  </a:tcPr>
-                </a:tc>
-                <a:tc>
-                  <a:txBody>
-                    <a:bodyPr wrap="square"/>
-                    <a:lstStyle/>
-                    <a:p>
-                      <a:pPr algn="ctr"/>
-                      <a:r>
-                        <a:rPr sz="950" b="0">
-                          <a:solidFill>
-                            <a:srgbClr val="5A6372"/>
-                          </a:solidFill>
-                          <a:latin typeface="맑은 고딕"/>
-                          <a:ea typeface="맑은 고딕"/>
-                        </a:rPr>
-                        <a:t>–</a:t>
-                      </a:r>
-                    </a:p>
-                  </a:txBody>
-                  <a:tcPr anchor="ctr" marL="50800" marR="50800" marT="25400" marB="25400">
-                    <a:solidFill>
-                      <a:srgbClr val="EEF2F7"/>
-                    </a:solidFill>
-                  </a:tcPr>
-                </a:tc>
-                <a:tc>
-                  <a:txBody>
-                    <a:bodyPr wrap="square"/>
-                    <a:lstStyle/>
-                    <a:p>
-                      <a:pPr algn="ctr"/>
-                      <a:r>
-                        <a:rPr sz="950" b="0">
-                          <a:solidFill>
-                            <a:srgbClr val="5A6372"/>
-                          </a:solidFill>
-                          <a:latin typeface="맑은 고딕"/>
-                          <a:ea typeface="맑은 고딕"/>
-                        </a:rPr>
-                        <a:t>–</a:t>
-                      </a:r>
-                    </a:p>
-                  </a:txBody>
-                  <a:tcPr anchor="ctr" marL="50800" marR="50800" marT="25400" marB="25400">
-                    <a:solidFill>
-                      <a:srgbClr val="EEF2F7"/>
-                    </a:solidFill>
-                  </a:tcPr>
-                </a:tc>
-              </a:tr>
-              <a:tr h="797356">
-                <a:tc>
-                  <a:txBody>
-                    <a:bodyPr wrap="square"/>
-                    <a:lstStyle/>
-                    <a:p>
-                      <a:pPr algn="ctr"/>
-                      <a:r>
-                        <a:rPr sz="1050" b="1">
-                          <a:solidFill>
-                            <a:srgbClr val="2E6DB4"/>
-                          </a:solidFill>
-                          <a:latin typeface="맑은 고딕"/>
-                          <a:ea typeface="맑은 고딕"/>
-                        </a:rPr>
-                        <a:t>예금</a:t>
-                      </a:r>
-                    </a:p>
-                  </a:txBody>
-                  <a:tcPr anchor="ctr" marL="50800" marR="50800" marT="25400" marB="25400">
-                    <a:solidFill>
-                      <a:srgbClr val="EFF3F9"/>
-                    </a:solidFill>
-                  </a:tcPr>
-                </a:tc>
-                <a:tc>
-                  <a:txBody>
-                    <a:bodyPr wrap="square"/>
-                    <a:lstStyle/>
-                    <a:p>
-                      <a:pPr>
-                        <a:spcAft>
-                          <a:spcPts val="100"/>
-                        </a:spcAft>
-                      </a:pPr>
-                      <a:r>
-                        <a:rPr sz="1050" b="1">
-                          <a:solidFill>
-                            <a:srgbClr val="142A4C"/>
-                          </a:solidFill>
-                          <a:latin typeface="맑은 고딕"/>
-                          <a:ea typeface="맑은 고딕"/>
-                        </a:rPr>
-                        <a:t>한국증권금융 정기예금</a:t>
+                        <a:t>원리금보장 · 예금자보호(1인 1억원) · AAA 최고 신용등급</a:t>
                       </a:r>
                     </a:p>
                     <a:p>
@@ -5464,24 +5242,103 @@
                           <a:latin typeface="맑은 고딕"/>
                           <a:ea typeface="맑은 고딕"/>
                         </a:rPr>
-                        <a:t>원리금보장 · 예금자보호(1인 1억원) · AAA 최고 신용등급</a:t>
-                      </a:r>
-                    </a:p>
-                    <a:p>
-                      <a:pPr>
-                        <a:lnSpc>
-                          <a:spcPct val="100000"/>
-                        </a:lnSpc>
-                      </a:pPr>
-                      <a:r>
-                        <a:rPr sz="830" b="0">
+                        <a:t>위험자산 변동성에 대한 안전판(확정금리) 역할</a:t>
+                      </a:r>
+                    </a:p>
+                  </a:txBody>
+                  <a:tcPr anchor="ctr" marL="50800" marR="50800" marT="25400" marB="25400">
+                    <a:solidFill>
+                      <a:srgbClr val="EFF3F9"/>
+                    </a:solidFill>
+                  </a:tcPr>
+                </a:tc>
+                <a:tc>
+                  <a:txBody>
+                    <a:bodyPr wrap="square"/>
+                    <a:lstStyle/>
+                    <a:p>
+                      <a:pPr algn="ctr"/>
+                      <a:r>
+                        <a:rPr sz="900" b="1">
+                          <a:solidFill>
+                            <a:srgbClr val="2E6DB4"/>
+                          </a:solidFill>
+                          <a:latin typeface="맑은 고딕"/>
+                          <a:ea typeface="맑은 고딕"/>
+                        </a:rPr>
+                        <a:t>매우낮은위험</a:t>
+                      </a:r>
+                    </a:p>
+                  </a:txBody>
+                  <a:tcPr anchor="ctr" marL="50800" marR="50800" marT="25400" marB="25400">
+                    <a:solidFill>
+                      <a:srgbClr val="EFF3F9"/>
+                    </a:solidFill>
+                  </a:tcPr>
+                </a:tc>
+                <a:tc>
+                  <a:txBody>
+                    <a:bodyPr wrap="square"/>
+                    <a:lstStyle/>
+                    <a:p>
+                      <a:pPr algn="ctr"/>
+                      <a:r>
+                        <a:rPr sz="1300" b="1">
+                          <a:solidFill>
+                            <a:srgbClr val="2E6DB4"/>
+                          </a:solidFill>
+                          <a:latin typeface="맑은 고딕"/>
+                          <a:ea typeface="맑은 고딕"/>
+                        </a:rPr>
+                        <a:t>70</a:t>
+                      </a:r>
+                    </a:p>
+                  </a:txBody>
+                  <a:tcPr anchor="ctr" marL="50800" marR="50800" marT="25400" marB="25400">
+                    <a:solidFill>
+                      <a:srgbClr val="EFF3F9"/>
+                    </a:solidFill>
+                  </a:tcPr>
+                </a:tc>
+                <a:tc>
+                  <a:txBody>
+                    <a:bodyPr wrap="square"/>
+                    <a:lstStyle/>
+                    <a:p>
+                      <a:pPr algn="ctr"/>
+                      <a:r>
+                        <a:rPr sz="1100" b="1">
+                          <a:solidFill>
+                            <a:srgbClr val="2E6DB4"/>
+                          </a:solidFill>
+                          <a:latin typeface="맑은 고딕"/>
+                          <a:ea typeface="맑은 고딕"/>
+                        </a:rPr>
+                        <a:t>3.70</a:t>
+                      </a:r>
+                    </a:p>
+                  </a:txBody>
+                  <a:tcPr anchor="ctr" marL="50800" marR="50800" marT="25400" marB="25400">
+                    <a:solidFill>
+                      <a:srgbClr val="EFF3F9"/>
+                    </a:solidFill>
+                  </a:tcPr>
+                </a:tc>
+                <a:tc>
+                  <a:txBody>
+                    <a:bodyPr wrap="square"/>
+                    <a:lstStyle/>
+                    <a:p>
+                      <a:pPr algn="ctr"/>
+                      <a:r>
+                        <a:rPr sz="900" b="0">
                           <a:solidFill>
                             <a:srgbClr val="5A6372"/>
                           </a:solidFill>
                           <a:latin typeface="맑은 고딕"/>
                           <a:ea typeface="맑은 고딕"/>
                         </a:rPr>
-                        <a:t>위험자산 변동성에 대한 안전판(확정금리) 역할</a:t>
+                        <a:t>–</a:t>
                       </a:r>
                     </a:p>
                   </a:txBody>
@@ -5498,14 +5355,14 @@
                     <a:p>
                       <a:pPr algn="ctr"/>
                       <a:r>
-                        <a:rPr sz="900" b="1">
-                          <a:solidFill>
-                            <a:srgbClr val="2E6DB4"/>
-                          </a:solidFill>
-                          <a:latin typeface="맑은 고딕"/>
-                          <a:ea typeface="맑은 고딕"/>
-                        </a:rPr>
-                        <a:t>매우낮은위험</a:t>
+                        <a:rPr sz="900" b="0">
+                          <a:solidFill>
+                            <a:srgbClr val="5A6372"/>
+                          </a:solidFill>
+                          <a:latin typeface="맑은 고딕"/>
+                          <a:ea typeface="맑은 고딕"/>
+                        </a:rPr>
+                        <a:t>–</a:t>
                       </a:r>
                     </a:p>
                   </a:txBody>
@@ -5522,14 +5379,14 @@
                     <a:p>
                       <a:pPr algn="ctr"/>
                       <a:r>
-                        <a:rPr sz="1300" b="1">
-                          <a:solidFill>
-                            <a:srgbClr val="2E6DB4"/>
-                          </a:solidFill>
-                          <a:latin typeface="맑은 고딕"/>
-                          <a:ea typeface="맑은 고딕"/>
-                        </a:rPr>
-                        <a:t>70</a:t>
+                        <a:rPr sz="900" b="0">
+                          <a:solidFill>
+                            <a:srgbClr val="5A6372"/>
+                          </a:solidFill>
+                          <a:latin typeface="맑은 고딕"/>
+                          <a:ea typeface="맑은 고딕"/>
+                        </a:rPr>
+                        <a:t>–</a:t>
                       </a:r>
                     </a:p>
                   </a:txBody>
@@ -5546,103 +5403,7 @@
                     <a:p>
                       <a:pPr algn="ctr"/>
                       <a:r>
-                        <a:rPr sz="1100" b="1">
-                          <a:solidFill>
-                            <a:srgbClr val="2E6DB4"/>
-                          </a:solidFill>
-                          <a:latin typeface="맑은 고딕"/>
-                          <a:ea typeface="맑은 고딕"/>
-                        </a:rPr>
-                        <a:t>3.70</a:t>
-                      </a:r>
-                    </a:p>
-                  </a:txBody>
-                  <a:tcPr anchor="ctr" marL="50800" marR="50800" marT="25400" marB="25400">
-                    <a:solidFill>
-                      <a:srgbClr val="EFF3F9"/>
-                    </a:solidFill>
-                  </a:tcPr>
-                </a:tc>
-                <a:tc>
-                  <a:txBody>
-                    <a:bodyPr wrap="square"/>
-                    <a:lstStyle/>
-                    <a:p>
-                      <a:pPr algn="ctr"/>
-                      <a:r>
-                        <a:rPr sz="950" b="0">
-                          <a:solidFill>
-                            <a:srgbClr val="5A6372"/>
-                          </a:solidFill>
-                          <a:latin typeface="맑은 고딕"/>
-                          <a:ea typeface="맑은 고딕"/>
-                        </a:rPr>
-                        <a:t>–</a:t>
-                      </a:r>
-                    </a:p>
-                  </a:txBody>
-                  <a:tcPr anchor="ctr" marL="50800" marR="50800" marT="25400" marB="25400">
-                    <a:solidFill>
-                      <a:srgbClr val="EFF3F9"/>
-                    </a:solidFill>
-                  </a:tcPr>
-                </a:tc>
-                <a:tc>
-                  <a:txBody>
-                    <a:bodyPr wrap="square"/>
-                    <a:lstStyle/>
-                    <a:p>
-                      <a:pPr algn="ctr"/>
-                      <a:r>
-                        <a:rPr sz="950" b="0">
-                          <a:solidFill>
-                            <a:srgbClr val="5A6372"/>
-                          </a:solidFill>
-                          <a:latin typeface="맑은 고딕"/>
-                          <a:ea typeface="맑은 고딕"/>
-                        </a:rPr>
-                        <a:t>–</a:t>
-                      </a:r>
-                    </a:p>
-                  </a:txBody>
-                  <a:tcPr anchor="ctr" marL="50800" marR="50800" marT="25400" marB="25400">
-                    <a:solidFill>
-                      <a:srgbClr val="EFF3F9"/>
-                    </a:solidFill>
-                  </a:tcPr>
-                </a:tc>
-                <a:tc>
-                  <a:txBody>
-                    <a:bodyPr wrap="square"/>
-                    <a:lstStyle/>
-                    <a:p>
-                      <a:pPr algn="ctr"/>
-                      <a:r>
-                        <a:rPr sz="950" b="0">
-                          <a:solidFill>
-                            <a:srgbClr val="5A6372"/>
-                          </a:solidFill>
-                          <a:latin typeface="맑은 고딕"/>
-                          <a:ea typeface="맑은 고딕"/>
-                        </a:rPr>
-                        <a:t>–</a:t>
-                      </a:r>
-                    </a:p>
-                  </a:txBody>
-                  <a:tcPr anchor="ctr" marL="50800" marR="50800" marT="25400" marB="25400">
-                    <a:solidFill>
-                      <a:srgbClr val="EFF3F9"/>
-                    </a:solidFill>
-                  </a:tcPr>
-                </a:tc>
-                <a:tc>
-                  <a:txBody>
-                    <a:bodyPr wrap="square"/>
-                    <a:lstStyle/>
-                    <a:p>
-                      <a:pPr algn="ctr"/>
-                      <a:r>
-                        <a:rPr sz="950" b="0">
+                        <a:rPr sz="900" b="0">
                           <a:solidFill>
                             <a:srgbClr val="5A6372"/>
                           </a:solidFill>
@@ -5692,14 +5453,14 @@
               </a:lnSpc>
             </a:pPr>
             <a:r>
-              <a:rPr sz="750" b="0">
+              <a:rPr sz="730" b="0">
                 <a:solidFill>
                   <a:srgbClr val="5A6372"/>
                 </a:solidFill>
                 <a:latin typeface="맑은 고딕"/>
                 <a:ea typeface="맑은 고딕"/>
               </a:rPr>
-              <a:t>※ 기간별 수익률은 확인 후 입력(출처: KG제로인/FnGuide 등, 기준일 기재) · ETF는 실적배당으로 원금 손실 가능 · 예금은 1년만기 세전 금리, 금리적용기간 2026.7.1~7.31</a:t>
+              <a:t>※ 기간별 수익률(1·3·6개월·1년)은 과거 성과로 미래 수익을 보장하지 않으며, 상승(+)은 적색·하락(−)은 청색 · ETF는 실적배당으로 원금 손실 가능 · 예금은 1년만기 세전 금리, 금리적용기간 2026.7.1~7.31</a:t>
             </a:r>
           </a:p>
         </p:txBody>
@@ -5894,7 +5655,7 @@
                 <a:latin typeface="맑은 고딕"/>
                 <a:ea typeface="맑은 고딕"/>
               </a:rPr>
-              <a:t>원금 안정성을 최우선. 안전자산(예금)으로 확정금리를 확보하고, 위험자산은 AI·반도체 핵심에 집중하되 파킹형으로 변동성을 완충합니다.</a:t>
+              <a:t>원금 안정성을 최우선. 안전자산(예금) 70%로 확정금리를 확보하고, 위험자산은 미국·한국 반도체와 글로벌 AI 핵심에 집중합니다.</a:t>
             </a:r>
           </a:p>
           <a:p>
@@ -6512,7 +6273,7 @@
         </p:nvGraphicFramePr>
         <p:xfrm>
           <a:off x="457200" y="1234440"/>
-          <a:ext cx="7635240" cy="4572000"/>
+          <a:ext cx="7635240" cy="4571996"/>
         </p:xfrm>
         <a:graphic>
           <a:graphicData uri="http://schemas.openxmlformats.org/drawingml/2006/table">
@@ -6871,7 +6632,7 @@
                   </a:tcPr>
                 </a:tc>
               </a:tr>
-              <a:tr h="664464">
+              <a:tr h="797356">
                 <a:tc>
                   <a:txBody>
                     <a:bodyPr wrap="square"/>
@@ -6979,7 +6740,7 @@
                           <a:latin typeface="맑은 고딕"/>
                           <a:ea typeface="맑은 고딕"/>
                         </a:rPr>
-                        <a:t>18</a:t>
+                        <a:t>20</a:t>
                       </a:r>
                     </a:p>
                   </a:txBody>
@@ -7020,14 +6781,14 @@
                     <a:p>
                       <a:pPr algn="ctr"/>
                       <a:r>
-                        <a:rPr sz="950" b="0">
-                          <a:solidFill>
-                            <a:srgbClr val="5A6372"/>
-                          </a:solidFill>
-                          <a:latin typeface="맑은 고딕"/>
-                          <a:ea typeface="맑은 고딕"/>
-                        </a:rPr>
-                        <a:t>–</a:t>
+                        <a:rPr sz="900" b="1">
+                          <a:solidFill>
+                            <a:srgbClr val="1F6FB2"/>
+                          </a:solidFill>
+                          <a:latin typeface="맑은 고딕"/>
+                          <a:ea typeface="맑은 고딕"/>
+                        </a:rPr>
+                        <a:t>-7.72</a:t>
                       </a:r>
                     </a:p>
                   </a:txBody>
@@ -7044,14 +6805,14 @@
                     <a:p>
                       <a:pPr algn="ctr"/>
                       <a:r>
-                        <a:rPr sz="950" b="0">
-                          <a:solidFill>
-                            <a:srgbClr val="5A6372"/>
-                          </a:solidFill>
-                          <a:latin typeface="맑은 고딕"/>
-                          <a:ea typeface="맑은 고딕"/>
-                        </a:rPr>
-                        <a:t>–</a:t>
+                        <a:rPr sz="900" b="1">
+                          <a:solidFill>
+                            <a:srgbClr val="C0392B"/>
+                          </a:solidFill>
+                          <a:latin typeface="맑은 고딕"/>
+                          <a:ea typeface="맑은 고딕"/>
+                        </a:rPr>
+                        <a:t>+36.51</a:t>
                       </a:r>
                     </a:p>
                   </a:txBody>
@@ -7068,14 +6829,14 @@
                     <a:p>
                       <a:pPr algn="ctr"/>
                       <a:r>
-                        <a:rPr sz="950" b="0">
-                          <a:solidFill>
-                            <a:srgbClr val="5A6372"/>
-                          </a:solidFill>
-                          <a:latin typeface="맑은 고딕"/>
-                          <a:ea typeface="맑은 고딕"/>
-                        </a:rPr>
-                        <a:t>–</a:t>
+                        <a:rPr sz="900" b="1">
+                          <a:solidFill>
+                            <a:srgbClr val="C0392B"/>
+                          </a:solidFill>
+                          <a:latin typeface="맑은 고딕"/>
+                          <a:ea typeface="맑은 고딕"/>
+                        </a:rPr>
+                        <a:t>+62.40</a:t>
                       </a:r>
                     </a:p>
                   </a:txBody>
@@ -7092,14 +6853,14 @@
                     <a:p>
                       <a:pPr algn="ctr"/>
                       <a:r>
-                        <a:rPr sz="950" b="0">
-                          <a:solidFill>
-                            <a:srgbClr val="5A6372"/>
-                          </a:solidFill>
-                          <a:latin typeface="맑은 고딕"/>
-                          <a:ea typeface="맑은 고딕"/>
-                        </a:rPr>
-                        <a:t>–</a:t>
+                        <a:rPr sz="900" b="1">
+                          <a:solidFill>
+                            <a:srgbClr val="C0392B"/>
+                          </a:solidFill>
+                          <a:latin typeface="맑은 고딕"/>
+                          <a:ea typeface="맑은 고딕"/>
+                        </a:rPr>
+                        <a:t>+133.88</a:t>
                       </a:r>
                     </a:p>
                   </a:txBody>
@@ -7110,7 +6871,7 @@
                   </a:tcPr>
                 </a:tc>
               </a:tr>
-              <a:tr h="664464">
+              <a:tr h="797356">
                 <a:tc>
                   <a:txBody>
                     <a:bodyPr wrap="square"/>
@@ -7218,7 +6979,7 @@
                           <a:latin typeface="맑은 고딕"/>
                           <a:ea typeface="맑은 고딕"/>
                         </a:rPr>
-                        <a:t>14</a:t>
+                        <a:t>15</a:t>
                       </a:r>
                     </a:p>
                   </a:txBody>
@@ -7259,14 +7020,14 @@
                     <a:p>
                       <a:pPr algn="ctr"/>
                       <a:r>
-                        <a:rPr sz="950" b="0">
-                          <a:solidFill>
-                            <a:srgbClr val="5A6372"/>
-                          </a:solidFill>
-                          <a:latin typeface="맑은 고딕"/>
-                          <a:ea typeface="맑은 고딕"/>
-                        </a:rPr>
-                        <a:t>–</a:t>
+                        <a:rPr sz="900" b="1">
+                          <a:solidFill>
+                            <a:srgbClr val="1F6FB2"/>
+                          </a:solidFill>
+                          <a:latin typeface="맑은 고딕"/>
+                          <a:ea typeface="맑은 고딕"/>
+                        </a:rPr>
+                        <a:t>-12.27</a:t>
                       </a:r>
                     </a:p>
                   </a:txBody>
@@ -7283,14 +7044,14 @@
                     <a:p>
                       <a:pPr algn="ctr"/>
                       <a:r>
-                        <a:rPr sz="950" b="0">
-                          <a:solidFill>
-                            <a:srgbClr val="5A6372"/>
-                          </a:solidFill>
-                          <a:latin typeface="맑은 고딕"/>
-                          <a:ea typeface="맑은 고딕"/>
-                        </a:rPr>
-                        <a:t>–</a:t>
+                        <a:rPr sz="900" b="1">
+                          <a:solidFill>
+                            <a:srgbClr val="C0392B"/>
+                          </a:solidFill>
+                          <a:latin typeface="맑은 고딕"/>
+                          <a:ea typeface="맑은 고딕"/>
+                        </a:rPr>
+                        <a:t>+23.93</a:t>
                       </a:r>
                     </a:p>
                   </a:txBody>
@@ -7307,14 +7068,14 @@
                     <a:p>
                       <a:pPr algn="ctr"/>
                       <a:r>
-                        <a:rPr sz="950" b="0">
-                          <a:solidFill>
-                            <a:srgbClr val="5A6372"/>
-                          </a:solidFill>
-                          <a:latin typeface="맑은 고딕"/>
-                          <a:ea typeface="맑은 고딕"/>
-                        </a:rPr>
-                        <a:t>–</a:t>
+                        <a:rPr sz="900" b="1">
+                          <a:solidFill>
+                            <a:srgbClr val="C0392B"/>
+                          </a:solidFill>
+                          <a:latin typeface="맑은 고딕"/>
+                          <a:ea typeface="맑은 고딕"/>
+                        </a:rPr>
+                        <a:t>+45.90</a:t>
                       </a:r>
                     </a:p>
                   </a:txBody>
@@ -7331,14 +7092,14 @@
                     <a:p>
                       <a:pPr algn="ctr"/>
                       <a:r>
-                        <a:rPr sz="950" b="0">
-                          <a:solidFill>
-                            <a:srgbClr val="5A6372"/>
-                          </a:solidFill>
-                          <a:latin typeface="맑은 고딕"/>
-                          <a:ea typeface="맑은 고딕"/>
-                        </a:rPr>
-                        <a:t>–</a:t>
+                        <a:rPr sz="900" b="1">
+                          <a:solidFill>
+                            <a:srgbClr val="C0392B"/>
+                          </a:solidFill>
+                          <a:latin typeface="맑은 고딕"/>
+                          <a:ea typeface="맑은 고딕"/>
+                        </a:rPr>
+                        <a:t>+94.51</a:t>
                       </a:r>
                     </a:p>
                   </a:txBody>
@@ -7349,7 +7110,7 @@
                   </a:tcPr>
                 </a:tc>
               </a:tr>
-              <a:tr h="664464">
+              <a:tr h="797356">
                 <a:tc>
                   <a:txBody>
                     <a:bodyPr wrap="square"/>
@@ -7392,7 +7153,7 @@
                           <a:latin typeface="맑은 고딕"/>
                           <a:ea typeface="맑은 고딕"/>
                         </a:rPr>
-                        <a:t>TIGER 코리아TOP10</a:t>
+                        <a:t>TIGER 반도체TOP10</a:t>
                       </a:r>
                     </a:p>
                     <a:p>
@@ -7409,7 +7170,7 @@
                           <a:latin typeface="맑은 고딕"/>
                           <a:ea typeface="맑은 고딕"/>
                         </a:rPr>
-                        <a:t>국내 시총 상위 10종목 · 메모리 부족·CAPEX 확산의 한국 반도체 수혜</a:t>
+                        <a:t>국내 반도체 시총 상위 10종목 · 메모리 부족·CAPEX 확산의 한국 반도체 집중 수혜</a:t>
                       </a:r>
                     </a:p>
                   </a:txBody>
@@ -7428,12 +7189,12 @@
                       <a:r>
                         <a:rPr sz="900" b="1">
                           <a:solidFill>
-                            <a:srgbClr val="E0671B"/>
-                          </a:solidFill>
-                          <a:latin typeface="맑은 고딕"/>
-                          <a:ea typeface="맑은 고딕"/>
-                        </a:rPr>
-                        <a:t>높은위험</a:t>
+                            <a:srgbClr val="C0392B"/>
+                          </a:solidFill>
+                          <a:latin typeface="맑은 고딕"/>
+                          <a:ea typeface="맑은 고딕"/>
+                        </a:rPr>
+                        <a:t>매우높은위험</a:t>
                       </a:r>
                     </a:p>
                   </a:txBody>
@@ -7457,7 +7218,7 @@
                           <a:latin typeface="맑은 고딕"/>
                           <a:ea typeface="맑은 고딕"/>
                         </a:rPr>
-                        <a:t>10</a:t>
+                        <a:t>11</a:t>
                       </a:r>
                     </a:p>
                   </a:txBody>
@@ -7498,14 +7259,14 @@
                     <a:p>
                       <a:pPr algn="ctr"/>
                       <a:r>
-                        <a:rPr sz="950" b="0">
-                          <a:solidFill>
-                            <a:srgbClr val="5A6372"/>
-                          </a:solidFill>
-                          <a:latin typeface="맑은 고딕"/>
-                          <a:ea typeface="맑은 고딕"/>
-                        </a:rPr>
-                        <a:t>–</a:t>
+                        <a:rPr sz="900" b="1">
+                          <a:solidFill>
+                            <a:srgbClr val="1F6FB2"/>
+                          </a:solidFill>
+                          <a:latin typeface="맑은 고딕"/>
+                          <a:ea typeface="맑은 고딕"/>
+                        </a:rPr>
+                        <a:t>-32.23</a:t>
                       </a:r>
                     </a:p>
                   </a:txBody>
@@ -7522,14 +7283,14 @@
                     <a:p>
                       <a:pPr algn="ctr"/>
                       <a:r>
-                        <a:rPr sz="950" b="0">
-                          <a:solidFill>
-                            <a:srgbClr val="5A6372"/>
-                          </a:solidFill>
-                          <a:latin typeface="맑은 고딕"/>
-                          <a:ea typeface="맑은 고딕"/>
-                        </a:rPr>
-                        <a:t>–</a:t>
+                        <a:rPr sz="900" b="1">
+                          <a:solidFill>
+                            <a:srgbClr val="C0392B"/>
+                          </a:solidFill>
+                          <a:latin typeface="맑은 고딕"/>
+                          <a:ea typeface="맑은 고딕"/>
+                        </a:rPr>
+                        <a:t>+3.82</a:t>
                       </a:r>
                     </a:p>
                   </a:txBody>
@@ -7546,14 +7307,14 @@
                     <a:p>
                       <a:pPr algn="ctr"/>
                       <a:r>
-                        <a:rPr sz="950" b="0">
-                          <a:solidFill>
-                            <a:srgbClr val="5A6372"/>
-                          </a:solidFill>
-                          <a:latin typeface="맑은 고딕"/>
-                          <a:ea typeface="맑은 고딕"/>
-                        </a:rPr>
-                        <a:t>–</a:t>
+                        <a:rPr sz="900" b="1">
+                          <a:solidFill>
+                            <a:srgbClr val="C0392B"/>
+                          </a:solidFill>
+                          <a:latin typeface="맑은 고딕"/>
+                          <a:ea typeface="맑은 고딕"/>
+                        </a:rPr>
+                        <a:t>+54.79</a:t>
                       </a:r>
                     </a:p>
                   </a:txBody>
@@ -7570,14 +7331,14 @@
                     <a:p>
                       <a:pPr algn="ctr"/>
                       <a:r>
-                        <a:rPr sz="950" b="0">
-                          <a:solidFill>
-                            <a:srgbClr val="5A6372"/>
-                          </a:solidFill>
-                          <a:latin typeface="맑은 고딕"/>
-                          <a:ea typeface="맑은 고딕"/>
-                        </a:rPr>
-                        <a:t>–</a:t>
+                        <a:rPr sz="900" b="1">
+                          <a:solidFill>
+                            <a:srgbClr val="C0392B"/>
+                          </a:solidFill>
+                          <a:latin typeface="맑은 고딕"/>
+                          <a:ea typeface="맑은 고딕"/>
+                        </a:rPr>
+                        <a:t>+198.59</a:t>
                       </a:r>
                     </a:p>
                   </a:txBody>
@@ -7588,7 +7349,7 @@
                   </a:tcPr>
                 </a:tc>
               </a:tr>
-              <a:tr h="664464">
+              <a:tr h="797356">
                 <a:tc>
                   <a:txBody>
                     <a:bodyPr wrap="square"/>
@@ -7696,7 +7457,7 @@
                           <a:latin typeface="맑은 고딕"/>
                           <a:ea typeface="맑은 고딕"/>
                         </a:rPr>
-                        <a:t>3</a:t>
+                        <a:t>4</a:t>
                       </a:r>
                     </a:p>
                   </a:txBody>
@@ -7737,14 +7498,14 @@
                     <a:p>
                       <a:pPr algn="ctr"/>
                       <a:r>
-                        <a:rPr sz="950" b="0">
-                          <a:solidFill>
-                            <a:srgbClr val="5A6372"/>
-                          </a:solidFill>
-                          <a:latin typeface="맑은 고딕"/>
-                          <a:ea typeface="맑은 고딕"/>
-                        </a:rPr>
-                        <a:t>–</a:t>
+                        <a:rPr sz="900" b="1">
+                          <a:solidFill>
+                            <a:srgbClr val="C0392B"/>
+                          </a:solidFill>
+                          <a:latin typeface="맑은 고딕"/>
+                          <a:ea typeface="맑은 고딕"/>
+                        </a:rPr>
+                        <a:t>+19.25</a:t>
                       </a:r>
                     </a:p>
                   </a:txBody>
@@ -7761,14 +7522,14 @@
                     <a:p>
                       <a:pPr algn="ctr"/>
                       <a:r>
-                        <a:rPr sz="950" b="0">
-                          <a:solidFill>
-                            <a:srgbClr val="5A6372"/>
-                          </a:solidFill>
-                          <a:latin typeface="맑은 고딕"/>
-                          <a:ea typeface="맑은 고딕"/>
-                        </a:rPr>
-                        <a:t>–</a:t>
+                        <a:rPr sz="900" b="1">
+                          <a:solidFill>
+                            <a:srgbClr val="C0392B"/>
+                          </a:solidFill>
+                          <a:latin typeface="맑은 고딕"/>
+                          <a:ea typeface="맑은 고딕"/>
+                        </a:rPr>
+                        <a:t>+71.73</a:t>
                       </a:r>
                     </a:p>
                   </a:txBody>
@@ -7785,14 +7546,14 @@
                     <a:p>
                       <a:pPr algn="ctr"/>
                       <a:r>
-                        <a:rPr sz="950" b="0">
-                          <a:solidFill>
-                            <a:srgbClr val="5A6372"/>
-                          </a:solidFill>
-                          <a:latin typeface="맑은 고딕"/>
-                          <a:ea typeface="맑은 고딕"/>
-                        </a:rPr>
-                        <a:t>–</a:t>
+                        <a:rPr sz="900" b="1">
+                          <a:solidFill>
+                            <a:srgbClr val="C0392B"/>
+                          </a:solidFill>
+                          <a:latin typeface="맑은 고딕"/>
+                          <a:ea typeface="맑은 고딕"/>
+                        </a:rPr>
+                        <a:t>+71.26</a:t>
                       </a:r>
                     </a:p>
                   </a:txBody>
@@ -7809,14 +7570,14 @@
                     <a:p>
                       <a:pPr algn="ctr"/>
                       <a:r>
-                        <a:rPr sz="950" b="0">
-                          <a:solidFill>
-                            <a:srgbClr val="5A6372"/>
-                          </a:solidFill>
-                          <a:latin typeface="맑은 고딕"/>
-                          <a:ea typeface="맑은 고딕"/>
-                        </a:rPr>
-                        <a:t>–</a:t>
+                        <a:rPr sz="900" b="1">
+                          <a:solidFill>
+                            <a:srgbClr val="C0392B"/>
+                          </a:solidFill>
+                          <a:latin typeface="맑은 고딕"/>
+                          <a:ea typeface="맑은 고딕"/>
+                        </a:rPr>
+                        <a:t>+187.44</a:t>
                       </a:r>
                     </a:p>
                   </a:txBody>
@@ -7827,7 +7588,7 @@
                   </a:tcPr>
                 </a:tc>
               </a:tr>
-              <a:tr h="664464">
+              <a:tr h="797356">
                 <a:tc>
                   <a:txBody>
                     <a:bodyPr wrap="square"/>
@@ -7837,18 +7598,18 @@
                       <a:r>
                         <a:rPr sz="1050" b="1">
                           <a:solidFill>
-                            <a:srgbClr val="F26A1B"/>
-                          </a:solidFill>
-                          <a:latin typeface="맑은 고딕"/>
-                          <a:ea typeface="맑은 고딕"/>
-                        </a:rPr>
-                        <a:t>ETF</a:t>
-                      </a:r>
-                    </a:p>
-                  </a:txBody>
-                  <a:tcPr anchor="ctr" marL="50800" marR="50800" marT="25400" marB="25400">
-                    <a:solidFill>
-                      <a:srgbClr val="FFFFFF"/>
+                            <a:srgbClr val="2E6DB4"/>
+                          </a:solidFill>
+                          <a:latin typeface="맑은 고딕"/>
+                          <a:ea typeface="맑은 고딕"/>
+                        </a:rPr>
+                        <a:t>예금</a:t>
+                      </a:r>
+                    </a:p>
+                  </a:txBody>
+                  <a:tcPr anchor="ctr" marL="50800" marR="50800" marT="25400" marB="25400">
+                    <a:solidFill>
+                      <a:srgbClr val="EFF3F9"/>
                     </a:solidFill>
                   </a:tcPr>
                 </a:tc>
@@ -7865,12 +7626,12 @@
                       <a:r>
                         <a:rPr sz="1050" b="1">
                           <a:solidFill>
-                            <a:srgbClr val="222A38"/>
-                          </a:solidFill>
-                          <a:latin typeface="맑은 고딕"/>
-                          <a:ea typeface="맑은 고딕"/>
-                        </a:rPr>
-                        <a:t>TIGER CD금리플러스액티브</a:t>
+                            <a:srgbClr val="142A4C"/>
+                          </a:solidFill>
+                          <a:latin typeface="맑은 고딕"/>
+                          <a:ea typeface="맑은 고딕"/>
+                        </a:rPr>
+                        <a:t>한국증권금융 정기예금</a:t>
                       </a:r>
                     </a:p>
                     <a:p>
@@ -7887,229 +7648,7 @@
                           <a:latin typeface="맑은 고딕"/>
                           <a:ea typeface="맑은 고딕"/>
                         </a:rPr>
-                        <a:t>국내 91일물 CD금리 추종 파킹형 · 시장 변동성 확대 대비 유동성 확보</a:t>
-                      </a:r>
-                    </a:p>
-                  </a:txBody>
-                  <a:tcPr anchor="ctr" marL="50800" marR="50800" marT="25400" marB="25400">
-                    <a:solidFill>
-                      <a:srgbClr val="FFFFFF"/>
-                    </a:solidFill>
-                  </a:tcPr>
-                </a:tc>
-                <a:tc>
-                  <a:txBody>
-                    <a:bodyPr wrap="square"/>
-                    <a:lstStyle/>
-                    <a:p>
-                      <a:pPr algn="ctr"/>
-                      <a:r>
-                        <a:rPr sz="900" b="1">
-                          <a:solidFill>
-                            <a:srgbClr val="C99A06"/>
-                          </a:solidFill>
-                          <a:latin typeface="맑은 고딕"/>
-                          <a:ea typeface="맑은 고딕"/>
-                        </a:rPr>
-                        <a:t>보통위험</a:t>
-                      </a:r>
-                    </a:p>
-                  </a:txBody>
-                  <a:tcPr anchor="ctr" marL="50800" marR="50800" marT="25400" marB="25400">
-                    <a:solidFill>
-                      <a:srgbClr val="FFFFFF"/>
-                    </a:solidFill>
-                  </a:tcPr>
-                </a:tc>
-                <a:tc>
-                  <a:txBody>
-                    <a:bodyPr wrap="square"/>
-                    <a:lstStyle/>
-                    <a:p>
-                      <a:pPr algn="ctr"/>
-                      <a:r>
-                        <a:rPr sz="1300" b="1">
-                          <a:solidFill>
-                            <a:srgbClr val="F26A1B"/>
-                          </a:solidFill>
-                          <a:latin typeface="맑은 고딕"/>
-                          <a:ea typeface="맑은 고딕"/>
-                        </a:rPr>
-                        <a:t>5</a:t>
-                      </a:r>
-                    </a:p>
-                  </a:txBody>
-                  <a:tcPr anchor="ctr" marL="50800" marR="50800" marT="25400" marB="25400">
-                    <a:solidFill>
-                      <a:srgbClr val="FFFFFF"/>
-                    </a:solidFill>
-                  </a:tcPr>
-                </a:tc>
-                <a:tc>
-                  <a:txBody>
-                    <a:bodyPr wrap="square"/>
-                    <a:lstStyle/>
-                    <a:p>
-                      <a:pPr algn="ctr"/>
-                      <a:r>
-                        <a:rPr sz="1050" b="0">
-                          <a:solidFill>
-                            <a:srgbClr val="5A6372"/>
-                          </a:solidFill>
-                          <a:latin typeface="맑은 고딕"/>
-                          <a:ea typeface="맑은 고딕"/>
-                        </a:rPr>
-                        <a:t>–</a:t>
-                      </a:r>
-                    </a:p>
-                  </a:txBody>
-                  <a:tcPr anchor="ctr" marL="50800" marR="50800" marT="25400" marB="25400">
-                    <a:solidFill>
-                      <a:srgbClr val="FFFFFF"/>
-                    </a:solidFill>
-                  </a:tcPr>
-                </a:tc>
-                <a:tc>
-                  <a:txBody>
-                    <a:bodyPr wrap="square"/>
-                    <a:lstStyle/>
-                    <a:p>
-                      <a:pPr algn="ctr"/>
-                      <a:r>
-                        <a:rPr sz="950" b="0">
-                          <a:solidFill>
-                            <a:srgbClr val="5A6372"/>
-                          </a:solidFill>
-                          <a:latin typeface="맑은 고딕"/>
-                          <a:ea typeface="맑은 고딕"/>
-                        </a:rPr>
-                        <a:t>–</a:t>
-                      </a:r>
-                    </a:p>
-                  </a:txBody>
-                  <a:tcPr anchor="ctr" marL="50800" marR="50800" marT="25400" marB="25400">
-                    <a:solidFill>
-                      <a:srgbClr val="FFFFFF"/>
-                    </a:solidFill>
-                  </a:tcPr>
-                </a:tc>
-                <a:tc>
-                  <a:txBody>
-                    <a:bodyPr wrap="square"/>
-                    <a:lstStyle/>
-                    <a:p>
-                      <a:pPr algn="ctr"/>
-                      <a:r>
-                        <a:rPr sz="950" b="0">
-                          <a:solidFill>
-                            <a:srgbClr val="5A6372"/>
-                          </a:solidFill>
-                          <a:latin typeface="맑은 고딕"/>
-                          <a:ea typeface="맑은 고딕"/>
-                        </a:rPr>
-                        <a:t>–</a:t>
-                      </a:r>
-                    </a:p>
-                  </a:txBody>
-                  <a:tcPr anchor="ctr" marL="50800" marR="50800" marT="25400" marB="25400">
-                    <a:solidFill>
-                      <a:srgbClr val="FFFFFF"/>
-                    </a:solidFill>
-                  </a:tcPr>
-                </a:tc>
-                <a:tc>
-                  <a:txBody>
-                    <a:bodyPr wrap="square"/>
-                    <a:lstStyle/>
-                    <a:p>
-                      <a:pPr algn="ctr"/>
-                      <a:r>
-                        <a:rPr sz="950" b="0">
-                          <a:solidFill>
-                            <a:srgbClr val="5A6372"/>
-                          </a:solidFill>
-                          <a:latin typeface="맑은 고딕"/>
-                          <a:ea typeface="맑은 고딕"/>
-                        </a:rPr>
-                        <a:t>–</a:t>
-                      </a:r>
-                    </a:p>
-                  </a:txBody>
-                  <a:tcPr anchor="ctr" marL="50800" marR="50800" marT="25400" marB="25400">
-                    <a:solidFill>
-                      <a:srgbClr val="FFFFFF"/>
-                    </a:solidFill>
-                  </a:tcPr>
-                </a:tc>
-                <a:tc>
-                  <a:txBody>
-                    <a:bodyPr wrap="square"/>
-                    <a:lstStyle/>
-                    <a:p>
-                      <a:pPr algn="ctr"/>
-                      <a:r>
-                        <a:rPr sz="950" b="0">
-                          <a:solidFill>
-                            <a:srgbClr val="5A6372"/>
-                          </a:solidFill>
-                          <a:latin typeface="맑은 고딕"/>
-                          <a:ea typeface="맑은 고딕"/>
-                        </a:rPr>
-                        <a:t>–</a:t>
-                      </a:r>
-                    </a:p>
-                  </a:txBody>
-                  <a:tcPr anchor="ctr" marL="50800" marR="50800" marT="25400" marB="25400">
-                    <a:solidFill>
-                      <a:srgbClr val="FFFFFF"/>
-                    </a:solidFill>
-                  </a:tcPr>
-                </a:tc>
-              </a:tr>
-              <a:tr h="664464">
-                <a:tc>
-                  <a:txBody>
-                    <a:bodyPr wrap="square"/>
-                    <a:lstStyle/>
-                    <a:p>
-                      <a:pPr algn="ctr"/>
-                      <a:r>
-                        <a:rPr sz="1050" b="1">
-                          <a:solidFill>
-                            <a:srgbClr val="2E6DB4"/>
-                          </a:solidFill>
-                          <a:latin typeface="맑은 고딕"/>
-                          <a:ea typeface="맑은 고딕"/>
-                        </a:rPr>
-                        <a:t>예금</a:t>
-                      </a:r>
-                    </a:p>
-                  </a:txBody>
-                  <a:tcPr anchor="ctr" marL="50800" marR="50800" marT="25400" marB="25400">
-                    <a:solidFill>
-                      <a:srgbClr val="EFF3F9"/>
-                    </a:solidFill>
-                  </a:tcPr>
-                </a:tc>
-                <a:tc>
-                  <a:txBody>
-                    <a:bodyPr wrap="square"/>
-                    <a:lstStyle/>
-                    <a:p>
-                      <a:pPr>
-                        <a:spcAft>
-                          <a:spcPts val="100"/>
-                        </a:spcAft>
-                      </a:pPr>
-                      <a:r>
-                        <a:rPr sz="1050" b="1">
-                          <a:solidFill>
-                            <a:srgbClr val="142A4C"/>
-                          </a:solidFill>
-                          <a:latin typeface="맑은 고딕"/>
-                          <a:ea typeface="맑은 고딕"/>
-                        </a:rPr>
-                        <a:t>한국증권금융 정기예금</a:t>
+                        <a:t>원리금보장 · 예금자보호(1인 1억원) · AAA 최고 신용등급</a:t>
                       </a:r>
                     </a:p>
                     <a:p>
@@ -8126,24 +7665,103 @@
                           <a:latin typeface="맑은 고딕"/>
                           <a:ea typeface="맑은 고딕"/>
                         </a:rPr>
-                        <a:t>원리금보장 · 예금자보호(1인 1억원) · AAA 최고 신용등급</a:t>
-                      </a:r>
-                    </a:p>
-                    <a:p>
-                      <a:pPr>
-                        <a:lnSpc>
-                          <a:spcPct val="100000"/>
-                        </a:lnSpc>
-                      </a:pPr>
-                      <a:r>
-                        <a:rPr sz="830" b="0">
+                        <a:t>위험자산 변동성에 대한 안전판(확정금리) 역할</a:t>
+                      </a:r>
+                    </a:p>
+                  </a:txBody>
+                  <a:tcPr anchor="ctr" marL="50800" marR="50800" marT="25400" marB="25400">
+                    <a:solidFill>
+                      <a:srgbClr val="EFF3F9"/>
+                    </a:solidFill>
+                  </a:tcPr>
+                </a:tc>
+                <a:tc>
+                  <a:txBody>
+                    <a:bodyPr wrap="square"/>
+                    <a:lstStyle/>
+                    <a:p>
+                      <a:pPr algn="ctr"/>
+                      <a:r>
+                        <a:rPr sz="900" b="1">
+                          <a:solidFill>
+                            <a:srgbClr val="2E6DB4"/>
+                          </a:solidFill>
+                          <a:latin typeface="맑은 고딕"/>
+                          <a:ea typeface="맑은 고딕"/>
+                        </a:rPr>
+                        <a:t>매우낮은위험</a:t>
+                      </a:r>
+                    </a:p>
+                  </a:txBody>
+                  <a:tcPr anchor="ctr" marL="50800" marR="50800" marT="25400" marB="25400">
+                    <a:solidFill>
+                      <a:srgbClr val="EFF3F9"/>
+                    </a:solidFill>
+                  </a:tcPr>
+                </a:tc>
+                <a:tc>
+                  <a:txBody>
+                    <a:bodyPr wrap="square"/>
+                    <a:lstStyle/>
+                    <a:p>
+                      <a:pPr algn="ctr"/>
+                      <a:r>
+                        <a:rPr sz="1300" b="1">
+                          <a:solidFill>
+                            <a:srgbClr val="2E6DB4"/>
+                          </a:solidFill>
+                          <a:latin typeface="맑은 고딕"/>
+                          <a:ea typeface="맑은 고딕"/>
+                        </a:rPr>
+                        <a:t>50</a:t>
+                      </a:r>
+                    </a:p>
+                  </a:txBody>
+                  <a:tcPr anchor="ctr" marL="50800" marR="50800" marT="25400" marB="25400">
+                    <a:solidFill>
+                      <a:srgbClr val="EFF3F9"/>
+                    </a:solidFill>
+                  </a:tcPr>
+                </a:tc>
+                <a:tc>
+                  <a:txBody>
+                    <a:bodyPr wrap="square"/>
+                    <a:lstStyle/>
+                    <a:p>
+                      <a:pPr algn="ctr"/>
+                      <a:r>
+                        <a:rPr sz="1100" b="1">
+                          <a:solidFill>
+                            <a:srgbClr val="2E6DB4"/>
+                          </a:solidFill>
+                          <a:latin typeface="맑은 고딕"/>
+                          <a:ea typeface="맑은 고딕"/>
+                        </a:rPr>
+                        <a:t>3.70</a:t>
+                      </a:r>
+                    </a:p>
+                  </a:txBody>
+                  <a:tcPr anchor="ctr" marL="50800" marR="50800" marT="25400" marB="25400">
+                    <a:solidFill>
+                      <a:srgbClr val="EFF3F9"/>
+                    </a:solidFill>
+                  </a:tcPr>
+                </a:tc>
+                <a:tc>
+                  <a:txBody>
+                    <a:bodyPr wrap="square"/>
+                    <a:lstStyle/>
+                    <a:p>
+                      <a:pPr algn="ctr"/>
+                      <a:r>
+                        <a:rPr sz="900" b="0">
                           <a:solidFill>
                             <a:srgbClr val="5A6372"/>
                           </a:solidFill>
                           <a:latin typeface="맑은 고딕"/>
                           <a:ea typeface="맑은 고딕"/>
                         </a:rPr>
-                        <a:t>위험자산 변동성에 대한 안전판(확정금리) 역할</a:t>
+                        <a:t>–</a:t>
                       </a:r>
                     </a:p>
                   </a:txBody>
@@ -8160,14 +7778,14 @@
                     <a:p>
                       <a:pPr algn="ctr"/>
                       <a:r>
-                        <a:rPr sz="900" b="1">
-                          <a:solidFill>
-                            <a:srgbClr val="2E6DB4"/>
-                          </a:solidFill>
-                          <a:latin typeface="맑은 고딕"/>
-                          <a:ea typeface="맑은 고딕"/>
-                        </a:rPr>
-                        <a:t>매우낮은위험</a:t>
+                        <a:rPr sz="900" b="0">
+                          <a:solidFill>
+                            <a:srgbClr val="5A6372"/>
+                          </a:solidFill>
+                          <a:latin typeface="맑은 고딕"/>
+                          <a:ea typeface="맑은 고딕"/>
+                        </a:rPr>
+                        <a:t>–</a:t>
                       </a:r>
                     </a:p>
                   </a:txBody>
@@ -8184,14 +7802,14 @@
                     <a:p>
                       <a:pPr algn="ctr"/>
                       <a:r>
-                        <a:rPr sz="1300" b="1">
-                          <a:solidFill>
-                            <a:srgbClr val="2E6DB4"/>
-                          </a:solidFill>
-                          <a:latin typeface="맑은 고딕"/>
-                          <a:ea typeface="맑은 고딕"/>
-                        </a:rPr>
-                        <a:t>50</a:t>
+                        <a:rPr sz="900" b="0">
+                          <a:solidFill>
+                            <a:srgbClr val="5A6372"/>
+                          </a:solidFill>
+                          <a:latin typeface="맑은 고딕"/>
+                          <a:ea typeface="맑은 고딕"/>
+                        </a:rPr>
+                        <a:t>–</a:t>
                       </a:r>
                     </a:p>
                   </a:txBody>
@@ -8208,103 +7826,7 @@
                     <a:p>
                       <a:pPr algn="ctr"/>
                       <a:r>
-                        <a:rPr sz="1100" b="1">
-                          <a:solidFill>
-                            <a:srgbClr val="2E6DB4"/>
-                          </a:solidFill>
-                          <a:latin typeface="맑은 고딕"/>
-                          <a:ea typeface="맑은 고딕"/>
-                        </a:rPr>
-                        <a:t>3.70</a:t>
-                      </a:r>
-                    </a:p>
-                  </a:txBody>
-                  <a:tcPr anchor="ctr" marL="50800" marR="50800" marT="25400" marB="25400">
-                    <a:solidFill>
-                      <a:srgbClr val="EFF3F9"/>
-                    </a:solidFill>
-                  </a:tcPr>
-                </a:tc>
-                <a:tc>
-                  <a:txBody>
-                    <a:bodyPr wrap="square"/>
-                    <a:lstStyle/>
-                    <a:p>
-                      <a:pPr algn="ctr"/>
-                      <a:r>
-                        <a:rPr sz="950" b="0">
-                          <a:solidFill>
-                            <a:srgbClr val="5A6372"/>
-                          </a:solidFill>
-                          <a:latin typeface="맑은 고딕"/>
-                          <a:ea typeface="맑은 고딕"/>
-                        </a:rPr>
-                        <a:t>–</a:t>
-                      </a:r>
-                    </a:p>
-                  </a:txBody>
-                  <a:tcPr anchor="ctr" marL="50800" marR="50800" marT="25400" marB="25400">
-                    <a:solidFill>
-                      <a:srgbClr val="EFF3F9"/>
-                    </a:solidFill>
-                  </a:tcPr>
-                </a:tc>
-                <a:tc>
-                  <a:txBody>
-                    <a:bodyPr wrap="square"/>
-                    <a:lstStyle/>
-                    <a:p>
-                      <a:pPr algn="ctr"/>
-                      <a:r>
-                        <a:rPr sz="950" b="0">
-                          <a:solidFill>
-                            <a:srgbClr val="5A6372"/>
-                          </a:solidFill>
-                          <a:latin typeface="맑은 고딕"/>
-                          <a:ea typeface="맑은 고딕"/>
-                        </a:rPr>
-                        <a:t>–</a:t>
-                      </a:r>
-                    </a:p>
-                  </a:txBody>
-                  <a:tcPr anchor="ctr" marL="50800" marR="50800" marT="25400" marB="25400">
-                    <a:solidFill>
-                      <a:srgbClr val="EFF3F9"/>
-                    </a:solidFill>
-                  </a:tcPr>
-                </a:tc>
-                <a:tc>
-                  <a:txBody>
-                    <a:bodyPr wrap="square"/>
-                    <a:lstStyle/>
-                    <a:p>
-                      <a:pPr algn="ctr"/>
-                      <a:r>
-                        <a:rPr sz="950" b="0">
-                          <a:solidFill>
-                            <a:srgbClr val="5A6372"/>
-                          </a:solidFill>
-                          <a:latin typeface="맑은 고딕"/>
-                          <a:ea typeface="맑은 고딕"/>
-                        </a:rPr>
-                        <a:t>–</a:t>
-                      </a:r>
-                    </a:p>
-                  </a:txBody>
-                  <a:tcPr anchor="ctr" marL="50800" marR="50800" marT="25400" marB="25400">
-                    <a:solidFill>
-                      <a:srgbClr val="EFF3F9"/>
-                    </a:solidFill>
-                  </a:tcPr>
-                </a:tc>
-                <a:tc>
-                  <a:txBody>
-                    <a:bodyPr wrap="square"/>
-                    <a:lstStyle/>
-                    <a:p>
-                      <a:pPr algn="ctr"/>
-                      <a:r>
-                        <a:rPr sz="950" b="0">
+                        <a:rPr sz="900" b="0">
                           <a:solidFill>
                             <a:srgbClr val="5A6372"/>
                           </a:solidFill>
@@ -8354,14 +7876,14 @@
               </a:lnSpc>
             </a:pPr>
             <a:r>
-              <a:rPr sz="750" b="0">
+              <a:rPr sz="730" b="0">
                 <a:solidFill>
                   <a:srgbClr val="5A6372"/>
                 </a:solidFill>
                 <a:latin typeface="맑은 고딕"/>
                 <a:ea typeface="맑은 고딕"/>
               </a:rPr>
-              <a:t>※ 기간별 수익률은 확인 후 입력(출처: KG제로인/FnGuide 등, 기준일 기재) · ETF는 실적배당으로 원금 손실 가능 · 예금은 1년만기 세전 금리, 금리적용기간 2026.7.1~7.31</a:t>
+              <a:t>※ 기간별 수익률(1·3·6개월·1년)은 과거 성과로 미래 수익을 보장하지 않으며, 상승(+)은 적색·하락(−)은 청색 · ETF는 실적배당으로 원금 손실 가능 · 예금은 1년만기 세전 금리, 금리적용기간 2026.7.1~7.31</a:t>
             </a:r>
           </a:p>
         </p:txBody>
@@ -8556,7 +8078,7 @@
                 <a:latin typeface="맑은 고딕"/>
                 <a:ea typeface="맑은 고딕"/>
               </a:rPr>
-              <a:t>수익과 안정의 균형. AI·반도체 코어를 확대하고 한국 대형주와 중국 반도체 위성을 더하며, 예금 50%로 하방을 방어합니다.</a:t>
+              <a:t>수익과 안정의 균형. 미국·한국 반도체와 글로벌 AI 코어에 중국 반도체 위성을 더하고, 예금 50%로 하방을 방어합니다.</a:t>
             </a:r>
           </a:p>
           <a:p>
@@ -9174,7 +8696,7 @@
         </p:nvGraphicFramePr>
         <p:xfrm>
           <a:off x="457200" y="1234440"/>
-          <a:ext cx="7635240" cy="4572000"/>
+          <a:ext cx="7635240" cy="4571996"/>
         </p:xfrm>
         <a:graphic>
           <a:graphicData uri="http://schemas.openxmlformats.org/drawingml/2006/table">
@@ -9533,7 +9055,7 @@
                   </a:tcPr>
                 </a:tc>
               </a:tr>
-              <a:tr h="664464">
+              <a:tr h="797356">
                 <a:tc>
                   <a:txBody>
                     <a:bodyPr wrap="square"/>
@@ -9641,7 +9163,7 @@
                           <a:latin typeface="맑은 고딕"/>
                           <a:ea typeface="맑은 고딕"/>
                         </a:rPr>
-                        <a:t>26</a:t>
+                        <a:t>28</a:t>
                       </a:r>
                     </a:p>
                   </a:txBody>
@@ -9682,14 +9204,14 @@
                     <a:p>
                       <a:pPr algn="ctr"/>
                       <a:r>
-                        <a:rPr sz="950" b="0">
-                          <a:solidFill>
-                            <a:srgbClr val="5A6372"/>
-                          </a:solidFill>
-                          <a:latin typeface="맑은 고딕"/>
-                          <a:ea typeface="맑은 고딕"/>
-                        </a:rPr>
-                        <a:t>–</a:t>
+                        <a:rPr sz="900" b="1">
+                          <a:solidFill>
+                            <a:srgbClr val="1F6FB2"/>
+                          </a:solidFill>
+                          <a:latin typeface="맑은 고딕"/>
+                          <a:ea typeface="맑은 고딕"/>
+                        </a:rPr>
+                        <a:t>-7.72</a:t>
                       </a:r>
                     </a:p>
                   </a:txBody>
@@ -9706,14 +9228,14 @@
                     <a:p>
                       <a:pPr algn="ctr"/>
                       <a:r>
-                        <a:rPr sz="950" b="0">
-                          <a:solidFill>
-                            <a:srgbClr val="5A6372"/>
-                          </a:solidFill>
-                          <a:latin typeface="맑은 고딕"/>
-                          <a:ea typeface="맑은 고딕"/>
-                        </a:rPr>
-                        <a:t>–</a:t>
+                        <a:rPr sz="900" b="1">
+                          <a:solidFill>
+                            <a:srgbClr val="C0392B"/>
+                          </a:solidFill>
+                          <a:latin typeface="맑은 고딕"/>
+                          <a:ea typeface="맑은 고딕"/>
+                        </a:rPr>
+                        <a:t>+36.51</a:t>
                       </a:r>
                     </a:p>
                   </a:txBody>
@@ -9730,14 +9252,14 @@
                     <a:p>
                       <a:pPr algn="ctr"/>
                       <a:r>
-                        <a:rPr sz="950" b="0">
-                          <a:solidFill>
-                            <a:srgbClr val="5A6372"/>
-                          </a:solidFill>
-                          <a:latin typeface="맑은 고딕"/>
-                          <a:ea typeface="맑은 고딕"/>
-                        </a:rPr>
-                        <a:t>–</a:t>
+                        <a:rPr sz="900" b="1">
+                          <a:solidFill>
+                            <a:srgbClr val="C0392B"/>
+                          </a:solidFill>
+                          <a:latin typeface="맑은 고딕"/>
+                          <a:ea typeface="맑은 고딕"/>
+                        </a:rPr>
+                        <a:t>+62.40</a:t>
                       </a:r>
                     </a:p>
                   </a:txBody>
@@ -9754,14 +9276,14 @@
                     <a:p>
                       <a:pPr algn="ctr"/>
                       <a:r>
-                        <a:rPr sz="950" b="0">
-                          <a:solidFill>
-                            <a:srgbClr val="5A6372"/>
-                          </a:solidFill>
-                          <a:latin typeface="맑은 고딕"/>
-                          <a:ea typeface="맑은 고딕"/>
-                        </a:rPr>
-                        <a:t>–</a:t>
+                        <a:rPr sz="900" b="1">
+                          <a:solidFill>
+                            <a:srgbClr val="C0392B"/>
+                          </a:solidFill>
+                          <a:latin typeface="맑은 고딕"/>
+                          <a:ea typeface="맑은 고딕"/>
+                        </a:rPr>
+                        <a:t>+133.88</a:t>
                       </a:r>
                     </a:p>
                   </a:txBody>
@@ -9772,7 +9294,7 @@
                   </a:tcPr>
                 </a:tc>
               </a:tr>
-              <a:tr h="664464">
+              <a:tr h="797356">
                 <a:tc>
                   <a:txBody>
                     <a:bodyPr wrap="square"/>
@@ -9880,7 +9402,7 @@
                           <a:latin typeface="맑은 고딕"/>
                           <a:ea typeface="맑은 고딕"/>
                         </a:rPr>
-                        <a:t>20</a:t>
+                        <a:t>22</a:t>
                       </a:r>
                     </a:p>
                   </a:txBody>
@@ -9921,14 +9443,14 @@
                     <a:p>
                       <a:pPr algn="ctr"/>
                       <a:r>
-                        <a:rPr sz="950" b="0">
-                          <a:solidFill>
-                            <a:srgbClr val="5A6372"/>
-                          </a:solidFill>
-                          <a:latin typeface="맑은 고딕"/>
-                          <a:ea typeface="맑은 고딕"/>
-                        </a:rPr>
-                        <a:t>–</a:t>
+                        <a:rPr sz="900" b="1">
+                          <a:solidFill>
+                            <a:srgbClr val="1F6FB2"/>
+                          </a:solidFill>
+                          <a:latin typeface="맑은 고딕"/>
+                          <a:ea typeface="맑은 고딕"/>
+                        </a:rPr>
+                        <a:t>-12.27</a:t>
                       </a:r>
                     </a:p>
                   </a:txBody>
@@ -9945,14 +9467,14 @@
                     <a:p>
                       <a:pPr algn="ctr"/>
                       <a:r>
-                        <a:rPr sz="950" b="0">
-                          <a:solidFill>
-                            <a:srgbClr val="5A6372"/>
-                          </a:solidFill>
-                          <a:latin typeface="맑은 고딕"/>
-                          <a:ea typeface="맑은 고딕"/>
-                        </a:rPr>
-                        <a:t>–</a:t>
+                        <a:rPr sz="900" b="1">
+                          <a:solidFill>
+                            <a:srgbClr val="C0392B"/>
+                          </a:solidFill>
+                          <a:latin typeface="맑은 고딕"/>
+                          <a:ea typeface="맑은 고딕"/>
+                        </a:rPr>
+                        <a:t>+23.93</a:t>
                       </a:r>
                     </a:p>
                   </a:txBody>
@@ -9969,14 +9491,14 @@
                     <a:p>
                       <a:pPr algn="ctr"/>
                       <a:r>
-                        <a:rPr sz="950" b="0">
-                          <a:solidFill>
-                            <a:srgbClr val="5A6372"/>
-                          </a:solidFill>
-                          <a:latin typeface="맑은 고딕"/>
-                          <a:ea typeface="맑은 고딕"/>
-                        </a:rPr>
-                        <a:t>–</a:t>
+                        <a:rPr sz="900" b="1">
+                          <a:solidFill>
+                            <a:srgbClr val="C0392B"/>
+                          </a:solidFill>
+                          <a:latin typeface="맑은 고딕"/>
+                          <a:ea typeface="맑은 고딕"/>
+                        </a:rPr>
+                        <a:t>+45.90</a:t>
                       </a:r>
                     </a:p>
                   </a:txBody>
@@ -9993,14 +9515,14 @@
                     <a:p>
                       <a:pPr algn="ctr"/>
                       <a:r>
-                        <a:rPr sz="950" b="0">
-                          <a:solidFill>
-                            <a:srgbClr val="5A6372"/>
-                          </a:solidFill>
-                          <a:latin typeface="맑은 고딕"/>
-                          <a:ea typeface="맑은 고딕"/>
-                        </a:rPr>
-                        <a:t>–</a:t>
+                        <a:rPr sz="900" b="1">
+                          <a:solidFill>
+                            <a:srgbClr val="C0392B"/>
+                          </a:solidFill>
+                          <a:latin typeface="맑은 고딕"/>
+                          <a:ea typeface="맑은 고딕"/>
+                        </a:rPr>
+                        <a:t>+94.51</a:t>
                       </a:r>
                     </a:p>
                   </a:txBody>
@@ -10011,7 +9533,7 @@
                   </a:tcPr>
                 </a:tc>
               </a:tr>
-              <a:tr h="664464">
+              <a:tr h="797356">
                 <a:tc>
                   <a:txBody>
                     <a:bodyPr wrap="square"/>
@@ -10054,7 +9576,7 @@
                           <a:latin typeface="맑은 고딕"/>
                           <a:ea typeface="맑은 고딕"/>
                         </a:rPr>
-                        <a:t>TIGER 코리아TOP10</a:t>
+                        <a:t>TIGER 반도체TOP10</a:t>
                       </a:r>
                     </a:p>
                     <a:p>
@@ -10071,7 +9593,7 @@
                           <a:latin typeface="맑은 고딕"/>
                           <a:ea typeface="맑은 고딕"/>
                         </a:rPr>
-                        <a:t>국내 시총 상위 10종목 · 메모리 부족·CAPEX 확산의 한국 반도체 수혜</a:t>
+                        <a:t>국내 반도체 시총 상위 10종목 · 메모리 부족·CAPEX 확산의 한국 반도체 집중 수혜</a:t>
                       </a:r>
                     </a:p>
                   </a:txBody>
@@ -10090,12 +9612,12 @@
                       <a:r>
                         <a:rPr sz="900" b="1">
                           <a:solidFill>
-                            <a:srgbClr val="E0671B"/>
-                          </a:solidFill>
-                          <a:latin typeface="맑은 고딕"/>
-                          <a:ea typeface="맑은 고딕"/>
-                        </a:rPr>
-                        <a:t>높은위험</a:t>
+                            <a:srgbClr val="C0392B"/>
+                          </a:solidFill>
+                          <a:latin typeface="맑은 고딕"/>
+                          <a:ea typeface="맑은 고딕"/>
+                        </a:rPr>
+                        <a:t>매우높은위험</a:t>
                       </a:r>
                     </a:p>
                   </a:txBody>
@@ -10160,14 +9682,14 @@
                     <a:p>
                       <a:pPr algn="ctr"/>
                       <a:r>
-                        <a:rPr sz="950" b="0">
-                          <a:solidFill>
-                            <a:srgbClr val="5A6372"/>
-                          </a:solidFill>
-                          <a:latin typeface="맑은 고딕"/>
-                          <a:ea typeface="맑은 고딕"/>
-                        </a:rPr>
-                        <a:t>–</a:t>
+                        <a:rPr sz="900" b="1">
+                          <a:solidFill>
+                            <a:srgbClr val="1F6FB2"/>
+                          </a:solidFill>
+                          <a:latin typeface="맑은 고딕"/>
+                          <a:ea typeface="맑은 고딕"/>
+                        </a:rPr>
+                        <a:t>-32.23</a:t>
                       </a:r>
                     </a:p>
                   </a:txBody>
@@ -10184,14 +9706,14 @@
                     <a:p>
                       <a:pPr algn="ctr"/>
                       <a:r>
-                        <a:rPr sz="950" b="0">
-                          <a:solidFill>
-                            <a:srgbClr val="5A6372"/>
-                          </a:solidFill>
-                          <a:latin typeface="맑은 고딕"/>
-                          <a:ea typeface="맑은 고딕"/>
-                        </a:rPr>
-                        <a:t>–</a:t>
+                        <a:rPr sz="900" b="1">
+                          <a:solidFill>
+                            <a:srgbClr val="C0392B"/>
+                          </a:solidFill>
+                          <a:latin typeface="맑은 고딕"/>
+                          <a:ea typeface="맑은 고딕"/>
+                        </a:rPr>
+                        <a:t>+3.82</a:t>
                       </a:r>
                     </a:p>
                   </a:txBody>
@@ -10208,14 +9730,14 @@
                     <a:p>
                       <a:pPr algn="ctr"/>
                       <a:r>
-                        <a:rPr sz="950" b="0">
-                          <a:solidFill>
-                            <a:srgbClr val="5A6372"/>
-                          </a:solidFill>
-                          <a:latin typeface="맑은 고딕"/>
-                          <a:ea typeface="맑은 고딕"/>
-                        </a:rPr>
-                        <a:t>–</a:t>
+                        <a:rPr sz="900" b="1">
+                          <a:solidFill>
+                            <a:srgbClr val="C0392B"/>
+                          </a:solidFill>
+                          <a:latin typeface="맑은 고딕"/>
+                          <a:ea typeface="맑은 고딕"/>
+                        </a:rPr>
+                        <a:t>+54.79</a:t>
                       </a:r>
                     </a:p>
                   </a:txBody>
@@ -10232,14 +9754,14 @@
                     <a:p>
                       <a:pPr algn="ctr"/>
                       <a:r>
-                        <a:rPr sz="950" b="0">
-                          <a:solidFill>
-                            <a:srgbClr val="5A6372"/>
-                          </a:solidFill>
-                          <a:latin typeface="맑은 고딕"/>
-                          <a:ea typeface="맑은 고딕"/>
-                        </a:rPr>
-                        <a:t>–</a:t>
+                        <a:rPr sz="900" b="1">
+                          <a:solidFill>
+                            <a:srgbClr val="C0392B"/>
+                          </a:solidFill>
+                          <a:latin typeface="맑은 고딕"/>
+                          <a:ea typeface="맑은 고딕"/>
+                        </a:rPr>
+                        <a:t>+198.59</a:t>
                       </a:r>
                     </a:p>
                   </a:txBody>
@@ -10250,7 +9772,7 @@
                   </a:tcPr>
                 </a:tc>
               </a:tr>
-              <a:tr h="664464">
+              <a:tr h="797356">
                 <a:tc>
                   <a:txBody>
                     <a:bodyPr wrap="square"/>
@@ -10399,14 +9921,14 @@
                     <a:p>
                       <a:pPr algn="ctr"/>
                       <a:r>
-                        <a:rPr sz="950" b="0">
-                          <a:solidFill>
-                            <a:srgbClr val="5A6372"/>
-                          </a:solidFill>
-                          <a:latin typeface="맑은 고딕"/>
-                          <a:ea typeface="맑은 고딕"/>
-                        </a:rPr>
-                        <a:t>–</a:t>
+                        <a:rPr sz="900" b="1">
+                          <a:solidFill>
+                            <a:srgbClr val="C0392B"/>
+                          </a:solidFill>
+                          <a:latin typeface="맑은 고딕"/>
+                          <a:ea typeface="맑은 고딕"/>
+                        </a:rPr>
+                        <a:t>+19.25</a:t>
                       </a:r>
                     </a:p>
                   </a:txBody>
@@ -10423,14 +9945,14 @@
                     <a:p>
                       <a:pPr algn="ctr"/>
                       <a:r>
-                        <a:rPr sz="950" b="0">
-                          <a:solidFill>
-                            <a:srgbClr val="5A6372"/>
-                          </a:solidFill>
-                          <a:latin typeface="맑은 고딕"/>
-                          <a:ea typeface="맑은 고딕"/>
-                        </a:rPr>
-                        <a:t>–</a:t>
+                        <a:rPr sz="900" b="1">
+                          <a:solidFill>
+                            <a:srgbClr val="C0392B"/>
+                          </a:solidFill>
+                          <a:latin typeface="맑은 고딕"/>
+                          <a:ea typeface="맑은 고딕"/>
+                        </a:rPr>
+                        <a:t>+71.73</a:t>
                       </a:r>
                     </a:p>
                   </a:txBody>
@@ -10447,14 +9969,14 @@
                     <a:p>
                       <a:pPr algn="ctr"/>
                       <a:r>
-                        <a:rPr sz="950" b="0">
-                          <a:solidFill>
-                            <a:srgbClr val="5A6372"/>
-                          </a:solidFill>
-                          <a:latin typeface="맑은 고딕"/>
-                          <a:ea typeface="맑은 고딕"/>
-                        </a:rPr>
-                        <a:t>–</a:t>
+                        <a:rPr sz="900" b="1">
+                          <a:solidFill>
+                            <a:srgbClr val="C0392B"/>
+                          </a:solidFill>
+                          <a:latin typeface="맑은 고딕"/>
+                          <a:ea typeface="맑은 고딕"/>
+                        </a:rPr>
+                        <a:t>+71.26</a:t>
                       </a:r>
                     </a:p>
                   </a:txBody>
@@ -10471,14 +9993,14 @@
                     <a:p>
                       <a:pPr algn="ctr"/>
                       <a:r>
-                        <a:rPr sz="950" b="0">
-                          <a:solidFill>
-                            <a:srgbClr val="5A6372"/>
-                          </a:solidFill>
-                          <a:latin typeface="맑은 고딕"/>
-                          <a:ea typeface="맑은 고딕"/>
-                        </a:rPr>
-                        <a:t>–</a:t>
+                        <a:rPr sz="900" b="1">
+                          <a:solidFill>
+                            <a:srgbClr val="C0392B"/>
+                          </a:solidFill>
+                          <a:latin typeface="맑은 고딕"/>
+                          <a:ea typeface="맑은 고딕"/>
+                        </a:rPr>
+                        <a:t>+187.44</a:t>
                       </a:r>
                     </a:p>
                   </a:txBody>
@@ -10489,7 +10011,7 @@
                   </a:tcPr>
                 </a:tc>
               </a:tr>
-              <a:tr h="664464">
+              <a:tr h="797356">
                 <a:tc>
                   <a:txBody>
                     <a:bodyPr wrap="square"/>
@@ -10499,18 +10021,18 @@
                       <a:r>
                         <a:rPr sz="1050" b="1">
                           <a:solidFill>
-                            <a:srgbClr val="F26A1B"/>
-                          </a:solidFill>
-                          <a:latin typeface="맑은 고딕"/>
-                          <a:ea typeface="맑은 고딕"/>
-                        </a:rPr>
-                        <a:t>ETF</a:t>
-                      </a:r>
-                    </a:p>
-                  </a:txBody>
-                  <a:tcPr anchor="ctr" marL="50800" marR="50800" marT="25400" marB="25400">
-                    <a:solidFill>
-                      <a:srgbClr val="FFFFFF"/>
+                            <a:srgbClr val="2E6DB4"/>
+                          </a:solidFill>
+                          <a:latin typeface="맑은 고딕"/>
+                          <a:ea typeface="맑은 고딕"/>
+                        </a:rPr>
+                        <a:t>예금</a:t>
+                      </a:r>
+                    </a:p>
+                  </a:txBody>
+                  <a:tcPr anchor="ctr" marL="50800" marR="50800" marT="25400" marB="25400">
+                    <a:solidFill>
+                      <a:srgbClr val="EFF3F9"/>
                     </a:solidFill>
                   </a:tcPr>
                 </a:tc>
@@ -10527,12 +10049,12 @@
                       <a:r>
                         <a:rPr sz="1050" b="1">
                           <a:solidFill>
-                            <a:srgbClr val="222A38"/>
-                          </a:solidFill>
-                          <a:latin typeface="맑은 고딕"/>
-                          <a:ea typeface="맑은 고딕"/>
-                        </a:rPr>
-                        <a:t>TIGER CD금리플러스액티브</a:t>
+                            <a:srgbClr val="142A4C"/>
+                          </a:solidFill>
+                          <a:latin typeface="맑은 고딕"/>
+                          <a:ea typeface="맑은 고딕"/>
+                        </a:rPr>
+                        <a:t>한국증권금융 정기예금</a:t>
                       </a:r>
                     </a:p>
                     <a:p>
@@ -10549,229 +10071,7 @@
                           <a:latin typeface="맑은 고딕"/>
                           <a:ea typeface="맑은 고딕"/>
                         </a:rPr>
-                        <a:t>국내 91일물 CD금리 추종 파킹형 · 시장 변동성 확대 대비 유동성 확보</a:t>
-                      </a:r>
-                    </a:p>
-                  </a:txBody>
-                  <a:tcPr anchor="ctr" marL="50800" marR="50800" marT="25400" marB="25400">
-                    <a:solidFill>
-                      <a:srgbClr val="FFFFFF"/>
-                    </a:solidFill>
-                  </a:tcPr>
-                </a:tc>
-                <a:tc>
-                  <a:txBody>
-                    <a:bodyPr wrap="square"/>
-                    <a:lstStyle/>
-                    <a:p>
-                      <a:pPr algn="ctr"/>
-                      <a:r>
-                        <a:rPr sz="900" b="1">
-                          <a:solidFill>
-                            <a:srgbClr val="C99A06"/>
-                          </a:solidFill>
-                          <a:latin typeface="맑은 고딕"/>
-                          <a:ea typeface="맑은 고딕"/>
-                        </a:rPr>
-                        <a:t>보통위험</a:t>
-                      </a:r>
-                    </a:p>
-                  </a:txBody>
-                  <a:tcPr anchor="ctr" marL="50800" marR="50800" marT="25400" marB="25400">
-                    <a:solidFill>
-                      <a:srgbClr val="FFFFFF"/>
-                    </a:solidFill>
-                  </a:tcPr>
-                </a:tc>
-                <a:tc>
-                  <a:txBody>
-                    <a:bodyPr wrap="square"/>
-                    <a:lstStyle/>
-                    <a:p>
-                      <a:pPr algn="ctr"/>
-                      <a:r>
-                        <a:rPr sz="1300" b="1">
-                          <a:solidFill>
-                            <a:srgbClr val="F26A1B"/>
-                          </a:solidFill>
-                          <a:latin typeface="맑은 고딕"/>
-                          <a:ea typeface="맑은 고딕"/>
-                        </a:rPr>
-                        <a:t>4</a:t>
-                      </a:r>
-                    </a:p>
-                  </a:txBody>
-                  <a:tcPr anchor="ctr" marL="50800" marR="50800" marT="25400" marB="25400">
-                    <a:solidFill>
-                      <a:srgbClr val="FFFFFF"/>
-                    </a:solidFill>
-                  </a:tcPr>
-                </a:tc>
-                <a:tc>
-                  <a:txBody>
-                    <a:bodyPr wrap="square"/>
-                    <a:lstStyle/>
-                    <a:p>
-                      <a:pPr algn="ctr"/>
-                      <a:r>
-                        <a:rPr sz="1050" b="0">
-                          <a:solidFill>
-                            <a:srgbClr val="5A6372"/>
-                          </a:solidFill>
-                          <a:latin typeface="맑은 고딕"/>
-                          <a:ea typeface="맑은 고딕"/>
-                        </a:rPr>
-                        <a:t>–</a:t>
-                      </a:r>
-                    </a:p>
-                  </a:txBody>
-                  <a:tcPr anchor="ctr" marL="50800" marR="50800" marT="25400" marB="25400">
-                    <a:solidFill>
-                      <a:srgbClr val="FFFFFF"/>
-                    </a:solidFill>
-                  </a:tcPr>
-                </a:tc>
-                <a:tc>
-                  <a:txBody>
-                    <a:bodyPr wrap="square"/>
-                    <a:lstStyle/>
-                    <a:p>
-                      <a:pPr algn="ctr"/>
-                      <a:r>
-                        <a:rPr sz="950" b="0">
-                          <a:solidFill>
-                            <a:srgbClr val="5A6372"/>
-                          </a:solidFill>
-                          <a:latin typeface="맑은 고딕"/>
-                          <a:ea typeface="맑은 고딕"/>
-                        </a:rPr>
-                        <a:t>–</a:t>
-                      </a:r>
-                    </a:p>
-                  </a:txBody>
-                  <a:tcPr anchor="ctr" marL="50800" marR="50800" marT="25400" marB="25400">
-                    <a:solidFill>
-                      <a:srgbClr val="FFFFFF"/>
-                    </a:solidFill>
-                  </a:tcPr>
-                </a:tc>
-                <a:tc>
-                  <a:txBody>
-                    <a:bodyPr wrap="square"/>
-                    <a:lstStyle/>
-                    <a:p>
-                      <a:pPr algn="ctr"/>
-                      <a:r>
-                        <a:rPr sz="950" b="0">
-                          <a:solidFill>
-                            <a:srgbClr val="5A6372"/>
-                          </a:solidFill>
-                          <a:latin typeface="맑은 고딕"/>
-                          <a:ea typeface="맑은 고딕"/>
-                        </a:rPr>
-                        <a:t>–</a:t>
-                      </a:r>
-                    </a:p>
-                  </a:txBody>
-                  <a:tcPr anchor="ctr" marL="50800" marR="50800" marT="25400" marB="25400">
-                    <a:solidFill>
-                      <a:srgbClr val="FFFFFF"/>
-                    </a:solidFill>
-                  </a:tcPr>
-                </a:tc>
-                <a:tc>
-                  <a:txBody>
-                    <a:bodyPr wrap="square"/>
-                    <a:lstStyle/>
-                    <a:p>
-                      <a:pPr algn="ctr"/>
-                      <a:r>
-                        <a:rPr sz="950" b="0">
-                          <a:solidFill>
-                            <a:srgbClr val="5A6372"/>
-                          </a:solidFill>
-                          <a:latin typeface="맑은 고딕"/>
-                          <a:ea typeface="맑은 고딕"/>
-                        </a:rPr>
-                        <a:t>–</a:t>
-                      </a:r>
-                    </a:p>
-                  </a:txBody>
-                  <a:tcPr anchor="ctr" marL="50800" marR="50800" marT="25400" marB="25400">
-                    <a:solidFill>
-                      <a:srgbClr val="FFFFFF"/>
-                    </a:solidFill>
-                  </a:tcPr>
-                </a:tc>
-                <a:tc>
-                  <a:txBody>
-                    <a:bodyPr wrap="square"/>
-                    <a:lstStyle/>
-                    <a:p>
-                      <a:pPr algn="ctr"/>
-                      <a:r>
-                        <a:rPr sz="950" b="0">
-                          <a:solidFill>
-                            <a:srgbClr val="5A6372"/>
-                          </a:solidFill>
-                          <a:latin typeface="맑은 고딕"/>
-                          <a:ea typeface="맑은 고딕"/>
-                        </a:rPr>
-                        <a:t>–</a:t>
-                      </a:r>
-                    </a:p>
-                  </a:txBody>
-                  <a:tcPr anchor="ctr" marL="50800" marR="50800" marT="25400" marB="25400">
-                    <a:solidFill>
-                      <a:srgbClr val="FFFFFF"/>
-                    </a:solidFill>
-                  </a:tcPr>
-                </a:tc>
-              </a:tr>
-              <a:tr h="664464">
-                <a:tc>
-                  <a:txBody>
-                    <a:bodyPr wrap="square"/>
-                    <a:lstStyle/>
-                    <a:p>
-                      <a:pPr algn="ctr"/>
-                      <a:r>
-                        <a:rPr sz="1050" b="1">
-                          <a:solidFill>
-                            <a:srgbClr val="2E6DB4"/>
-                          </a:solidFill>
-                          <a:latin typeface="맑은 고딕"/>
-                          <a:ea typeface="맑은 고딕"/>
-                        </a:rPr>
-                        <a:t>예금</a:t>
-                      </a:r>
-                    </a:p>
-                  </a:txBody>
-                  <a:tcPr anchor="ctr" marL="50800" marR="50800" marT="25400" marB="25400">
-                    <a:solidFill>
-                      <a:srgbClr val="EFF3F9"/>
-                    </a:solidFill>
-                  </a:tcPr>
-                </a:tc>
-                <a:tc>
-                  <a:txBody>
-                    <a:bodyPr wrap="square"/>
-                    <a:lstStyle/>
-                    <a:p>
-                      <a:pPr>
-                        <a:spcAft>
-                          <a:spcPts val="100"/>
-                        </a:spcAft>
-                      </a:pPr>
-                      <a:r>
-                        <a:rPr sz="1050" b="1">
-                          <a:solidFill>
-                            <a:srgbClr val="142A4C"/>
-                          </a:solidFill>
-                          <a:latin typeface="맑은 고딕"/>
-                          <a:ea typeface="맑은 고딕"/>
-                        </a:rPr>
-                        <a:t>한국증권금융 정기예금</a:t>
+                        <a:t>원리금보장 · 예금자보호(1인 1억원) · AAA 최고 신용등급</a:t>
                       </a:r>
                     </a:p>
                     <a:p>
@@ -10788,24 +10088,103 @@
                           <a:latin typeface="맑은 고딕"/>
                           <a:ea typeface="맑은 고딕"/>
                         </a:rPr>
-                        <a:t>원리금보장 · 예금자보호(1인 1억원) · AAA 최고 신용등급</a:t>
-                      </a:r>
-                    </a:p>
-                    <a:p>
-                      <a:pPr>
-                        <a:lnSpc>
-                          <a:spcPct val="100000"/>
-                        </a:lnSpc>
-                      </a:pPr>
-                      <a:r>
-                        <a:rPr sz="830" b="0">
+                        <a:t>위험자산 변동성에 대한 안전판(확정금리) 역할</a:t>
+                      </a:r>
+                    </a:p>
+                  </a:txBody>
+                  <a:tcPr anchor="ctr" marL="50800" marR="50800" marT="25400" marB="25400">
+                    <a:solidFill>
+                      <a:srgbClr val="EFF3F9"/>
+                    </a:solidFill>
+                  </a:tcPr>
+                </a:tc>
+                <a:tc>
+                  <a:txBody>
+                    <a:bodyPr wrap="square"/>
+                    <a:lstStyle/>
+                    <a:p>
+                      <a:pPr algn="ctr"/>
+                      <a:r>
+                        <a:rPr sz="900" b="1">
+                          <a:solidFill>
+                            <a:srgbClr val="2E6DB4"/>
+                          </a:solidFill>
+                          <a:latin typeface="맑은 고딕"/>
+                          <a:ea typeface="맑은 고딕"/>
+                        </a:rPr>
+                        <a:t>매우낮은위험</a:t>
+                      </a:r>
+                    </a:p>
+                  </a:txBody>
+                  <a:tcPr anchor="ctr" marL="50800" marR="50800" marT="25400" marB="25400">
+                    <a:solidFill>
+                      <a:srgbClr val="EFF3F9"/>
+                    </a:solidFill>
+                  </a:tcPr>
+                </a:tc>
+                <a:tc>
+                  <a:txBody>
+                    <a:bodyPr wrap="square"/>
+                    <a:lstStyle/>
+                    <a:p>
+                      <a:pPr algn="ctr"/>
+                      <a:r>
+                        <a:rPr sz="1300" b="1">
+                          <a:solidFill>
+                            <a:srgbClr val="2E6DB4"/>
+                          </a:solidFill>
+                          <a:latin typeface="맑은 고딕"/>
+                          <a:ea typeface="맑은 고딕"/>
+                        </a:rPr>
+                        <a:t>30</a:t>
+                      </a:r>
+                    </a:p>
+                  </a:txBody>
+                  <a:tcPr anchor="ctr" marL="50800" marR="50800" marT="25400" marB="25400">
+                    <a:solidFill>
+                      <a:srgbClr val="EFF3F9"/>
+                    </a:solidFill>
+                  </a:tcPr>
+                </a:tc>
+                <a:tc>
+                  <a:txBody>
+                    <a:bodyPr wrap="square"/>
+                    <a:lstStyle/>
+                    <a:p>
+                      <a:pPr algn="ctr"/>
+                      <a:r>
+                        <a:rPr sz="1100" b="1">
+                          <a:solidFill>
+                            <a:srgbClr val="2E6DB4"/>
+                          </a:solidFill>
+                          <a:latin typeface="맑은 고딕"/>
+                          <a:ea typeface="맑은 고딕"/>
+                        </a:rPr>
+                        <a:t>3.70</a:t>
+                      </a:r>
+                    </a:p>
+                  </a:txBody>
+                  <a:tcPr anchor="ctr" marL="50800" marR="50800" marT="25400" marB="25400">
+                    <a:solidFill>
+                      <a:srgbClr val="EFF3F9"/>
+                    </a:solidFill>
+                  </a:tcPr>
+                </a:tc>
+                <a:tc>
+                  <a:txBody>
+                    <a:bodyPr wrap="square"/>
+                    <a:lstStyle/>
+                    <a:p>
+                      <a:pPr algn="ctr"/>
+                      <a:r>
+                        <a:rPr sz="900" b="0">
                           <a:solidFill>
                             <a:srgbClr val="5A6372"/>
                           </a:solidFill>
                           <a:latin typeface="맑은 고딕"/>
                           <a:ea typeface="맑은 고딕"/>
                         </a:rPr>
-                        <a:t>위험자산 변동성에 대한 안전판(확정금리) 역할</a:t>
+                        <a:t>–</a:t>
                       </a:r>
                     </a:p>
                   </a:txBody>
@@ -10822,14 +10201,14 @@
                     <a:p>
                       <a:pPr algn="ctr"/>
                       <a:r>
-                        <a:rPr sz="900" b="1">
-                          <a:solidFill>
-                            <a:srgbClr val="2E6DB4"/>
-                          </a:solidFill>
-                          <a:latin typeface="맑은 고딕"/>
-                          <a:ea typeface="맑은 고딕"/>
-                        </a:rPr>
-                        <a:t>매우낮은위험</a:t>
+                        <a:rPr sz="900" b="0">
+                          <a:solidFill>
+                            <a:srgbClr val="5A6372"/>
+                          </a:solidFill>
+                          <a:latin typeface="맑은 고딕"/>
+                          <a:ea typeface="맑은 고딕"/>
+                        </a:rPr>
+                        <a:t>–</a:t>
                       </a:r>
                     </a:p>
                   </a:txBody>
@@ -10846,14 +10225,14 @@
                     <a:p>
                       <a:pPr algn="ctr"/>
                       <a:r>
-                        <a:rPr sz="1300" b="1">
-                          <a:solidFill>
-                            <a:srgbClr val="2E6DB4"/>
-                          </a:solidFill>
-                          <a:latin typeface="맑은 고딕"/>
-                          <a:ea typeface="맑은 고딕"/>
-                        </a:rPr>
-                        <a:t>30</a:t>
+                        <a:rPr sz="900" b="0">
+                          <a:solidFill>
+                            <a:srgbClr val="5A6372"/>
+                          </a:solidFill>
+                          <a:latin typeface="맑은 고딕"/>
+                          <a:ea typeface="맑은 고딕"/>
+                        </a:rPr>
+                        <a:t>–</a:t>
                       </a:r>
                     </a:p>
                   </a:txBody>
@@ -10870,103 +10249,7 @@
                     <a:p>
                       <a:pPr algn="ctr"/>
                       <a:r>
-                        <a:rPr sz="1100" b="1">
-                          <a:solidFill>
-                            <a:srgbClr val="2E6DB4"/>
-                          </a:solidFill>
-                          <a:latin typeface="맑은 고딕"/>
-                          <a:ea typeface="맑은 고딕"/>
-                        </a:rPr>
-                        <a:t>3.70</a:t>
-                      </a:r>
-                    </a:p>
-                  </a:txBody>
-                  <a:tcPr anchor="ctr" marL="50800" marR="50800" marT="25400" marB="25400">
-                    <a:solidFill>
-                      <a:srgbClr val="EFF3F9"/>
-                    </a:solidFill>
-                  </a:tcPr>
-                </a:tc>
-                <a:tc>
-                  <a:txBody>
-                    <a:bodyPr wrap="square"/>
-                    <a:lstStyle/>
-                    <a:p>
-                      <a:pPr algn="ctr"/>
-                      <a:r>
-                        <a:rPr sz="950" b="0">
-                          <a:solidFill>
-                            <a:srgbClr val="5A6372"/>
-                          </a:solidFill>
-                          <a:latin typeface="맑은 고딕"/>
-                          <a:ea typeface="맑은 고딕"/>
-                        </a:rPr>
-                        <a:t>–</a:t>
-                      </a:r>
-                    </a:p>
-                  </a:txBody>
-                  <a:tcPr anchor="ctr" marL="50800" marR="50800" marT="25400" marB="25400">
-                    <a:solidFill>
-                      <a:srgbClr val="EFF3F9"/>
-                    </a:solidFill>
-                  </a:tcPr>
-                </a:tc>
-                <a:tc>
-                  <a:txBody>
-                    <a:bodyPr wrap="square"/>
-                    <a:lstStyle/>
-                    <a:p>
-                      <a:pPr algn="ctr"/>
-                      <a:r>
-                        <a:rPr sz="950" b="0">
-                          <a:solidFill>
-                            <a:srgbClr val="5A6372"/>
-                          </a:solidFill>
-                          <a:latin typeface="맑은 고딕"/>
-                          <a:ea typeface="맑은 고딕"/>
-                        </a:rPr>
-                        <a:t>–</a:t>
-                      </a:r>
-                    </a:p>
-                  </a:txBody>
-                  <a:tcPr anchor="ctr" marL="50800" marR="50800" marT="25400" marB="25400">
-                    <a:solidFill>
-                      <a:srgbClr val="EFF3F9"/>
-                    </a:solidFill>
-                  </a:tcPr>
-                </a:tc>
-                <a:tc>
-                  <a:txBody>
-                    <a:bodyPr wrap="square"/>
-                    <a:lstStyle/>
-                    <a:p>
-                      <a:pPr algn="ctr"/>
-                      <a:r>
-                        <a:rPr sz="950" b="0">
-                          <a:solidFill>
-                            <a:srgbClr val="5A6372"/>
-                          </a:solidFill>
-                          <a:latin typeface="맑은 고딕"/>
-                          <a:ea typeface="맑은 고딕"/>
-                        </a:rPr>
-                        <a:t>–</a:t>
-                      </a:r>
-                    </a:p>
-                  </a:txBody>
-                  <a:tcPr anchor="ctr" marL="50800" marR="50800" marT="25400" marB="25400">
-                    <a:solidFill>
-                      <a:srgbClr val="EFF3F9"/>
-                    </a:solidFill>
-                  </a:tcPr>
-                </a:tc>
-                <a:tc>
-                  <a:txBody>
-                    <a:bodyPr wrap="square"/>
-                    <a:lstStyle/>
-                    <a:p>
-                      <a:pPr algn="ctr"/>
-                      <a:r>
-                        <a:rPr sz="950" b="0">
+                        <a:rPr sz="900" b="0">
                           <a:solidFill>
                             <a:srgbClr val="5A6372"/>
                           </a:solidFill>
@@ -11016,14 +10299,14 @@
               </a:lnSpc>
             </a:pPr>
             <a:r>
-              <a:rPr sz="750" b="0">
+              <a:rPr sz="730" b="0">
                 <a:solidFill>
                   <a:srgbClr val="5A6372"/>
                 </a:solidFill>
                 <a:latin typeface="맑은 고딕"/>
                 <a:ea typeface="맑은 고딕"/>
               </a:rPr>
-              <a:t>※ 기간별 수익률은 확인 후 입력(출처: KG제로인/FnGuide 등, 기준일 기재) · ETF는 실적배당으로 원금 손실 가능 · 예금은 1년만기 세전 금리, 금리적용기간 2026.7.1~7.31</a:t>
+              <a:t>※ 기간별 수익률(1·3·6개월·1년)은 과거 성과로 미래 수익을 보장하지 않으며, 상승(+)은 적색·하락(−)은 청색 · ETF는 실적배당으로 원금 손실 가능 · 예금은 1년만기 세전 금리, 금리적용기간 2026.7.1~7.31</a:t>
             </a:r>
           </a:p>
         </p:txBody>

</xml_diff>